<commit_message>
os: Update PR7499 scheduler scenario test deck to three slides
Add a problem statement slide comparing API tests with scenario
tests, and extend the solution slide with key design points.
</commit_message>
<xml_diff>
--- a/os/PR7499_Scheduler_Scenario_Tests.pptx
+++ b/os/PR7499_Scheduler_Scenario_Tests.pptx
@@ -7,9 +7,10 @@
   <p:sldIdLst>
     <p:sldId id="256" r:id="rId2"/>
     <p:sldId id="257" r:id="rId3"/>
+    <p:sldId id="258" r:id="rId4"/>
   </p:sldIdLst>
   <p:notesMasterIdLst>
-    <p:notesMasterId r:id="rId4"/>
+    <p:notesMasterId r:id="rId5"/>
   </p:notesMasterIdLst>
   <p:sldSz cx="9144000" cy="5143500"/>
   <p:notesSz cx="5143500" cy="9144000"/>
@@ -503,7 +504,7 @@
           <a:p>
             <a:r>
               <a:rPr lang="en-US" dirty="0"/>
-              <a:t>Background: API-level tests cannot detect scheduler misbehaviour on SMP. Solution: 12 scenario tests in 4 groups, built on a shared harness and a background starvation monitor. No kernel code changed.</a:t>
+              <a:t>Existing kernel tests only confirm that values are stored and returned. They cannot see whether the scheduler actually rotates, preempts or honours affinity. The new scenario tests apply real CPU load and judge the observed behaviour.</a:t>
             </a:r>
             <a:endParaRPr lang="en-US" dirty="0"/>
           </a:p>
@@ -591,7 +592,7 @@
           <a:p>
             <a:r>
               <a:rPr lang="en-US" dirty="0"/>
-              <a:t>Each scenario applies a controlled load, discards warm-up, measures work per task and CPU placement, cleans up, then asserts. Impact: early detection of SMP hang and deadlock bugs with zero product risk.</a:t>
+              <a:t>Twelve scenarios in four groups share one measurement harness. A background monitor watches for tasks stuck waiting. Everything sits above the kernel; the scheduler itself is untouched.</a:t>
             </a:r>
             <a:endParaRPr lang="en-US" dirty="0"/>
           </a:p>
@@ -615,6 +616,94 @@
             <a:fld id="{F7021451-1387-4CA6-816F-3879F97B5CBC}" type="slidenum">
               <a:rPr lang="en-US"/>
               <a:t>2</a:t>
+            </a:fld>
+            <a:endParaRPr lang="en-US"/>
+          </a:p>
+        </p:txBody>
+      </p:sp>
+    </p:spTree>
+    <p:extLst>
+      <p:ext uri="{BB962C8B-B14F-4D97-AF65-F5344CB8AC3E}">
+        <p14:creationId xmlns:p14="http://schemas.microsoft.com/office/powerpoint/2010/main" val="1024086991"/>
+      </p:ext>
+    </p:extLst>
+  </p:cSld>
+  <p:clrMapOvr>
+    <a:masterClrMapping/>
+  </p:clrMapOvr>
+</p:notes>
+</file>
+
+<file path=ppt/notesSlides/notesSlide3.xml><?xml version="1.0" encoding="utf-8"?>
+<p:notes xmlns:a="http://schemas.openxmlformats.org/drawingml/2006/main" xmlns:r="http://schemas.openxmlformats.org/officeDocument/2006/relationships" xmlns:p="http://schemas.openxmlformats.org/presentationml/2006/main">
+  <p:cSld>
+    <p:spTree>
+      <p:nvGrpSpPr>
+        <p:cNvPr id="1" name=""/>
+        <p:cNvGrpSpPr/>
+        <p:nvPr/>
+      </p:nvGrpSpPr>
+      <p:grpSpPr>
+        <a:xfrm>
+          <a:off x="0" y="0"/>
+          <a:ext cx="0" cy="0"/>
+          <a:chOff x="0" y="0"/>
+          <a:chExt cx="0" cy="0"/>
+        </a:xfrm>
+      </p:grpSpPr>
+      <p:sp>
+        <p:nvSpPr>
+          <p:cNvPr id="2" name="Slide Image Placeholder 1"/>
+          <p:cNvSpPr>
+            <a:spLocks noGrp="1" noRot="1" noChangeAspect="1"/>
+          </p:cNvSpPr>
+          <p:nvPr>
+            <p:ph type="sldImg"/>
+          </p:nvPr>
+        </p:nvSpPr>
+        <p:spPr/>
+      </p:sp>
+      <p:sp>
+        <p:nvSpPr>
+          <p:cNvPr id="3" name="Notes Placeholder 2"/>
+          <p:cNvSpPr>
+            <a:spLocks noGrp="1"/>
+          </p:cNvSpPr>
+          <p:nvPr>
+            <p:ph type="body" idx="1"/>
+          </p:nvPr>
+        </p:nvSpPr>
+        <p:spPr/>
+        <p:txBody>
+          <a:bodyPr/>
+          <a:lstStyle/>
+          <a:p>
+            <a:r>
+              <a:rPr lang="en-US" dirty="0"/>
+              <a:t>Each scenario applies a controlled load, discards warm-up, measures, cleans up, then gives a verdict. Impact: early detection of SMP hang and deadlock bugs with zero product risk.</a:t>
+            </a:r>
+            <a:endParaRPr lang="en-US" dirty="0"/>
+          </a:p>
+        </p:txBody>
+      </p:sp>
+      <p:sp>
+        <p:nvSpPr>
+          <p:cNvPr id="4" name="Slide Number Placeholder 3"/>
+          <p:cNvSpPr>
+            <a:spLocks noGrp="1"/>
+          </p:cNvSpPr>
+          <p:nvPr>
+            <p:ph type="sldNum" sz="quarter" idx="10"/>
+          </p:nvPr>
+        </p:nvSpPr>
+        <p:spPr/>
+        <p:txBody>
+          <a:bodyPr/>
+          <a:lstStyle/>
+          <a:p>
+            <a:fld id="{F7021451-1387-4CA6-816F-3879F97B5CBC}" type="slidenum">
+              <a:rPr lang="en-US"/>
+              <a:t>3</a:t>
             </a:fld>
             <a:endParaRPr lang="en-US"/>
           </a:p>
@@ -997,7 +1086,7 @@
                 <a:ea typeface="Cambria" pitchFamily="34" charset="-122"/>
                 <a:cs typeface="Cambria" pitchFamily="34" charset="-120"/>
               </a:rPr>
-              <a:t>SMP Scheduler Scenario Tests</a:t>
+              <a:t>Why SMP Scheduler Scenario Tests</a:t>
             </a:r>
             <a:endParaRPr lang="en-US" sz="2600" dirty="0"/>
           </a:p>
@@ -1051,11 +1140,11 @@
         <p:spPr>
           <a:xfrm>
             <a:off x="457200" y="1234440"/>
-            <a:ext cx="2286000" cy="3474720"/>
+            <a:ext cx="2651760" cy="3474720"/>
           </a:xfrm>
           <a:prstGeom prst="roundRect">
             <a:avLst>
-              <a:gd name="adj" fmla="val 3200"/>
+              <a:gd name="adj" fmla="val 2759"/>
             </a:avLst>
           </a:prstGeom>
           <a:solidFill>
@@ -1078,7 +1167,7 @@
         <p:spPr>
           <a:xfrm>
             <a:off x="640080" y="1371600"/>
-            <a:ext cx="1920240" cy="274320"/>
+            <a:ext cx="4114800" cy="274320"/>
           </a:xfrm>
           <a:prstGeom prst="rect">
             <a:avLst/>
@@ -1117,7 +1206,7 @@
         <p:spPr>
           <a:xfrm>
             <a:off x="640080" y="1737360"/>
-            <a:ext cx="1965960" cy="1828800"/>
+            <a:ext cx="2331720" cy="2011680"/>
           </a:xfrm>
           <a:prstGeom prst="rect">
             <a:avLst/>
@@ -1145,7 +1234,7 @@
                 <a:ea typeface="Calibri" pitchFamily="34" charset="-122"/>
                 <a:cs typeface="Calibri" pitchFamily="34" charset="-120"/>
               </a:rPr>
-              <a:t>SMP boards hit hangs and deadlocks.</a:t>
+              <a:t>Dual-core boards show hangs and deadlocks.</a:t>
             </a:r>
             <a:endParaRPr lang="en-US" sz="1300" dirty="0"/>
           </a:p>
@@ -1166,7 +1255,7 @@
                 <a:ea typeface="Calibri" pitchFamily="34" charset="-122"/>
                 <a:cs typeface="Calibri" pitchFamily="34" charset="-120"/>
               </a:rPr>
-              <a:t>Old tests check APIs, not behavior.</a:t>
+              <a:t>Root cause is often the scheduler.</a:t>
             </a:r>
             <a:endParaRPr lang="en-US" sz="1300" dirty="0"/>
           </a:p>
@@ -1187,6 +1276,27 @@
                 <a:ea typeface="Calibri" pitchFamily="34" charset="-122"/>
                 <a:cs typeface="Calibri" pitchFamily="34" charset="-120"/>
               </a:rPr>
+              <a:t>Current tests check APIs only.</a:t>
+            </a:r>
+            <a:endParaRPr lang="en-US" sz="1300" dirty="0"/>
+          </a:p>
+          <a:p>
+            <a:pPr marL="152400" indent="-152400">
+              <a:spcAft>
+                <a:spcPts val="800"/>
+              </a:spcAft>
+              <a:buSzPct val="100000"/>
+              <a:buChar char="•"/>
+            </a:pPr>
+            <a:r>
+              <a:rPr lang="en-US" sz="1300" dirty="0">
+                <a:solidFill>
+                  <a:srgbClr val="1F2937"/>
+                </a:solidFill>
+                <a:latin typeface="Calibri" pitchFamily="34" charset="0"/>
+                <a:ea typeface="Calibri" pitchFamily="34" charset="-122"/>
+                <a:cs typeface="Calibri" pitchFamily="34" charset="-120"/>
+              </a:rPr>
               <a:t>A broken scheduler still passes them.</a:t>
             </a:r>
             <a:endParaRPr lang="en-US" sz="1300" dirty="0"/>
@@ -1201,8 +1311,8 @@
         </p:nvSpPr>
         <p:spPr>
           <a:xfrm>
-            <a:off x="640080" y="3840480"/>
-            <a:ext cx="1965960" cy="640080"/>
+            <a:off x="640080" y="3977640"/>
+            <a:ext cx="2331720" cy="548640"/>
           </a:xfrm>
           <a:prstGeom prst="rect">
             <a:avLst/>
@@ -1226,7 +1336,7 @@
                 <a:ea typeface="Calibri" pitchFamily="34" charset="-122"/>
                 <a:cs typeface="Calibri" pitchFamily="34" charset="-120"/>
               </a:rPr>
-              <a:t>Gap: no check of real scheduling under load.</a:t>
+              <a:t>Field hangs are slow and costly to debug.</a:t>
             </a:r>
             <a:endParaRPr lang="en-US" sz="1100" dirty="0"/>
           </a:p>
@@ -1240,8 +1350,8 @@
         </p:nvSpPr>
         <p:spPr>
           <a:xfrm>
-            <a:off x="3017520" y="1234440"/>
-            <a:ext cx="3657600" cy="274320"/>
+            <a:off x="3383280" y="1234440"/>
+            <a:ext cx="4114800" cy="274320"/>
           </a:xfrm>
           <a:prstGeom prst="rect">
             <a:avLst/>
@@ -1265,7 +1375,7 @@
                 <a:ea typeface="Calibri" pitchFamily="34" charset="-122"/>
                 <a:cs typeface="Calibri" pitchFamily="34" charset="-120"/>
               </a:rPr>
-              <a:t>SOLUTION: WHAT WE ADDED</a:t>
+              <a:t>TODAY vs NEW APPROACH</a:t>
             </a:r>
             <a:endParaRPr lang="en-US" sz="1200" dirty="0"/>
           </a:p>
@@ -1273,18 +1383,381 @@
       </p:sp>
       <p:sp>
         <p:nvSpPr>
-          <p:cNvPr id="9" name="Shape 7"/>
+          <p:cNvPr id="9" name="Text 7"/>
+          <p:cNvSpPr txBox="1"/>
+          <p:nvPr/>
+        </p:nvSpPr>
+        <p:spPr>
+          <a:xfrm>
+            <a:off x="3383280" y="1645920"/>
+            <a:ext cx="5303520" cy="274320"/>
+          </a:xfrm>
+          <a:prstGeom prst="rect">
+            <a:avLst/>
+          </a:prstGeom>
+          <a:noFill/>
+          <a:ln/>
+        </p:spPr>
+        <p:txBody>
+          <a:bodyPr wrap="square" lIns="0" tIns="0" rIns="0" bIns="0" rtlCol="0" anchor="ctr"/>
+          <a:lstStyle/>
+          <a:p>
+            <a:pPr indent="0" marL="0">
+              <a:buNone/>
+            </a:pPr>
+            <a:r>
+              <a:rPr lang="en-US" sz="1300" b="1" dirty="0">
+                <a:solidFill>
+                  <a:srgbClr val="14213D"/>
+                </a:solidFill>
+                <a:latin typeface="Calibri" pitchFamily="34" charset="0"/>
+                <a:ea typeface="Calibri" pitchFamily="34" charset="-122"/>
+                <a:cs typeface="Calibri" pitchFamily="34" charset="-120"/>
+              </a:rPr>
+              <a:t>Today: API tests</a:t>
+            </a:r>
+            <a:endParaRPr lang="en-US" sz="1300" dirty="0"/>
+          </a:p>
+        </p:txBody>
+      </p:sp>
+      <p:sp>
+        <p:nvSpPr>
+          <p:cNvPr id="10" name="Shape 8"/>
           <p:cNvSpPr/>
           <p:nvPr/>
         </p:nvSpPr>
         <p:spPr>
           <a:xfrm>
-            <a:off x="6720840" y="1298448"/>
-            <a:ext cx="164592" cy="146304"/>
+            <a:off x="3383280" y="1993392"/>
+            <a:ext cx="1508760" cy="502920"/>
           </a:xfrm>
           <a:prstGeom prst="roundRect">
             <a:avLst>
-              <a:gd name="adj" fmla="val 50000"/>
+              <a:gd name="adj" fmla="val 14545"/>
+            </a:avLst>
+          </a:prstGeom>
+          <a:solidFill>
+            <a:srgbClr val="C9D1DB"/>
+          </a:solidFill>
+          <a:ln w="12700">
+            <a:solidFill>
+              <a:srgbClr val="C9D1DB"/>
+            </a:solidFill>
+            <a:prstDash val="solid"/>
+          </a:ln>
+        </p:spPr>
+      </p:sp>
+      <p:sp>
+        <p:nvSpPr>
+          <p:cNvPr id="11" name="Text 9"/>
+          <p:cNvSpPr txBox="1"/>
+          <p:nvPr/>
+        </p:nvSpPr>
+        <p:spPr>
+          <a:xfrm>
+            <a:off x="3383280" y="1993392"/>
+            <a:ext cx="1508760" cy="502920"/>
+          </a:xfrm>
+          <a:prstGeom prst="rect">
+            <a:avLst/>
+          </a:prstGeom>
+          <a:noFill/>
+          <a:ln/>
+        </p:spPr>
+        <p:txBody>
+          <a:bodyPr wrap="square" lIns="0" tIns="0" rIns="0" bIns="0" rtlCol="0" anchor="ctr"/>
+          <a:lstStyle/>
+          <a:p>
+            <a:pPr algn="ctr" indent="0" marL="0">
+              <a:buNone/>
+            </a:pPr>
+            <a:r>
+              <a:rPr lang="en-US" sz="1100" b="1" dirty="0">
+                <a:solidFill>
+                  <a:srgbClr val="1F2937"/>
+                </a:solidFill>
+                <a:latin typeface="Calibri" pitchFamily="34" charset="0"/>
+                <a:ea typeface="Calibri" pitchFamily="34" charset="-122"/>
+                <a:cs typeface="Calibri" pitchFamily="34" charset="-120"/>
+              </a:rPr>
+              <a:t>Set a value</a:t>
+            </a:r>
+            <a:endParaRPr lang="en-US" sz="1100" dirty="0"/>
+          </a:p>
+        </p:txBody>
+      </p:sp>
+      <p:sp>
+        <p:nvSpPr>
+          <p:cNvPr id="12" name="Shape 10"/>
+          <p:cNvSpPr/>
+          <p:nvPr/>
+        </p:nvSpPr>
+        <p:spPr>
+          <a:xfrm>
+            <a:off x="4919472" y="2244852"/>
+            <a:ext cx="265176" cy="0"/>
+          </a:xfrm>
+          <a:prstGeom prst="line">
+            <a:avLst/>
+          </a:prstGeom>
+          <a:noFill/>
+          <a:ln w="19050">
+            <a:solidFill>
+              <a:srgbClr val="6B7280"/>
+            </a:solidFill>
+            <a:prstDash val="solid"/>
+            <a:tailEnd type="triangle"/>
+          </a:ln>
+        </p:spPr>
+      </p:sp>
+      <p:sp>
+        <p:nvSpPr>
+          <p:cNvPr id="13" name="Shape 11"/>
+          <p:cNvSpPr/>
+          <p:nvPr/>
+        </p:nvSpPr>
+        <p:spPr>
+          <a:xfrm>
+            <a:off x="5212080" y="1993392"/>
+            <a:ext cx="1508760" cy="502920"/>
+          </a:xfrm>
+          <a:prstGeom prst="roundRect">
+            <a:avLst>
+              <a:gd name="adj" fmla="val 14545"/>
+            </a:avLst>
+          </a:prstGeom>
+          <a:solidFill>
+            <a:srgbClr val="C9D1DB"/>
+          </a:solidFill>
+          <a:ln w="12700">
+            <a:solidFill>
+              <a:srgbClr val="C9D1DB"/>
+            </a:solidFill>
+            <a:prstDash val="solid"/>
+          </a:ln>
+        </p:spPr>
+      </p:sp>
+      <p:sp>
+        <p:nvSpPr>
+          <p:cNvPr id="14" name="Text 12"/>
+          <p:cNvSpPr txBox="1"/>
+          <p:nvPr/>
+        </p:nvSpPr>
+        <p:spPr>
+          <a:xfrm>
+            <a:off x="5212080" y="1993392"/>
+            <a:ext cx="1508760" cy="502920"/>
+          </a:xfrm>
+          <a:prstGeom prst="rect">
+            <a:avLst/>
+          </a:prstGeom>
+          <a:noFill/>
+          <a:ln/>
+        </p:spPr>
+        <p:txBody>
+          <a:bodyPr wrap="square" lIns="0" tIns="0" rIns="0" bIns="0" rtlCol="0" anchor="ctr"/>
+          <a:lstStyle/>
+          <a:p>
+            <a:pPr algn="ctr" indent="0" marL="0">
+              <a:buNone/>
+            </a:pPr>
+            <a:r>
+              <a:rPr lang="en-US" sz="1100" b="1" dirty="0">
+                <a:solidFill>
+                  <a:srgbClr val="1F2937"/>
+                </a:solidFill>
+                <a:latin typeface="Calibri" pitchFamily="34" charset="0"/>
+                <a:ea typeface="Calibri" pitchFamily="34" charset="-122"/>
+                <a:cs typeface="Calibri" pitchFamily="34" charset="-120"/>
+              </a:rPr>
+              <a:t>Read it back</a:t>
+            </a:r>
+            <a:endParaRPr lang="en-US" sz="1100" dirty="0"/>
+          </a:p>
+        </p:txBody>
+      </p:sp>
+      <p:sp>
+        <p:nvSpPr>
+          <p:cNvPr id="15" name="Shape 13"/>
+          <p:cNvSpPr/>
+          <p:nvPr/>
+        </p:nvSpPr>
+        <p:spPr>
+          <a:xfrm>
+            <a:off x="6748272" y="2244852"/>
+            <a:ext cx="265176" cy="0"/>
+          </a:xfrm>
+          <a:prstGeom prst="line">
+            <a:avLst/>
+          </a:prstGeom>
+          <a:noFill/>
+          <a:ln w="19050">
+            <a:solidFill>
+              <a:srgbClr val="6B7280"/>
+            </a:solidFill>
+            <a:prstDash val="solid"/>
+            <a:tailEnd type="triangle"/>
+          </a:ln>
+        </p:spPr>
+      </p:sp>
+      <p:sp>
+        <p:nvSpPr>
+          <p:cNvPr id="16" name="Shape 14"/>
+          <p:cNvSpPr/>
+          <p:nvPr/>
+        </p:nvSpPr>
+        <p:spPr>
+          <a:xfrm>
+            <a:off x="7040880" y="1993392"/>
+            <a:ext cx="1508760" cy="502920"/>
+          </a:xfrm>
+          <a:prstGeom prst="roundRect">
+            <a:avLst>
+              <a:gd name="adj" fmla="val 14545"/>
+            </a:avLst>
+          </a:prstGeom>
+          <a:solidFill>
+            <a:srgbClr val="C9D1DB"/>
+          </a:solidFill>
+          <a:ln w="12700">
+            <a:solidFill>
+              <a:srgbClr val="C9D1DB"/>
+            </a:solidFill>
+            <a:prstDash val="solid"/>
+          </a:ln>
+        </p:spPr>
+      </p:sp>
+      <p:sp>
+        <p:nvSpPr>
+          <p:cNvPr id="17" name="Text 15"/>
+          <p:cNvSpPr txBox="1"/>
+          <p:nvPr/>
+        </p:nvSpPr>
+        <p:spPr>
+          <a:xfrm>
+            <a:off x="7040880" y="1993392"/>
+            <a:ext cx="1508760" cy="502920"/>
+          </a:xfrm>
+          <a:prstGeom prst="rect">
+            <a:avLst/>
+          </a:prstGeom>
+          <a:noFill/>
+          <a:ln/>
+        </p:spPr>
+        <p:txBody>
+          <a:bodyPr wrap="square" lIns="0" tIns="0" rIns="0" bIns="0" rtlCol="0" anchor="ctr"/>
+          <a:lstStyle/>
+          <a:p>
+            <a:pPr algn="ctr" indent="0" marL="0">
+              <a:buNone/>
+            </a:pPr>
+            <a:r>
+              <a:rPr lang="en-US" sz="1100" b="1" dirty="0">
+                <a:solidFill>
+                  <a:srgbClr val="1F2937"/>
+                </a:solidFill>
+                <a:latin typeface="Calibri" pitchFamily="34" charset="0"/>
+                <a:ea typeface="Calibri" pitchFamily="34" charset="-122"/>
+                <a:cs typeface="Calibri" pitchFamily="34" charset="-120"/>
+              </a:rPr>
+              <a:t>PASS</a:t>
+            </a:r>
+            <a:endParaRPr lang="en-US" sz="1100" dirty="0"/>
+          </a:p>
+        </p:txBody>
+      </p:sp>
+      <p:sp>
+        <p:nvSpPr>
+          <p:cNvPr id="18" name="Text 16"/>
+          <p:cNvSpPr txBox="1"/>
+          <p:nvPr/>
+        </p:nvSpPr>
+        <p:spPr>
+          <a:xfrm>
+            <a:off x="3383280" y="2560320"/>
+            <a:ext cx="5303520" cy="256032"/>
+          </a:xfrm>
+          <a:prstGeom prst="rect">
+            <a:avLst/>
+          </a:prstGeom>
+          <a:noFill/>
+          <a:ln/>
+        </p:spPr>
+        <p:txBody>
+          <a:bodyPr wrap="square" lIns="0" tIns="0" rIns="0" bIns="0" rtlCol="0" anchor="ctr"/>
+          <a:lstStyle/>
+          <a:p>
+            <a:pPr indent="0" marL="0">
+              <a:buNone/>
+            </a:pPr>
+            <a:r>
+              <a:rPr lang="en-US" sz="1100" i="1" dirty="0">
+                <a:solidFill>
+                  <a:srgbClr val="D1495B"/>
+                </a:solidFill>
+                <a:latin typeface="Calibri" pitchFamily="34" charset="0"/>
+                <a:ea typeface="Calibri" pitchFamily="34" charset="-122"/>
+                <a:cs typeface="Calibri" pitchFamily="34" charset="-120"/>
+              </a:rPr>
+              <a:t>Passes even if the scheduler is broken.</a:t>
+            </a:r>
+            <a:endParaRPr lang="en-US" sz="1100" dirty="0"/>
+          </a:p>
+        </p:txBody>
+      </p:sp>
+      <p:sp>
+        <p:nvSpPr>
+          <p:cNvPr id="19" name="Text 17"/>
+          <p:cNvSpPr txBox="1"/>
+          <p:nvPr/>
+        </p:nvSpPr>
+        <p:spPr>
+          <a:xfrm>
+            <a:off x="3383280" y="3063240"/>
+            <a:ext cx="5303520" cy="274320"/>
+          </a:xfrm>
+          <a:prstGeom prst="rect">
+            <a:avLst/>
+          </a:prstGeom>
+          <a:noFill/>
+          <a:ln/>
+        </p:spPr>
+        <p:txBody>
+          <a:bodyPr wrap="square" lIns="0" tIns="0" rIns="0" bIns="0" rtlCol="0" anchor="ctr"/>
+          <a:lstStyle/>
+          <a:p>
+            <a:pPr indent="0" marL="0">
+              <a:buNone/>
+            </a:pPr>
+            <a:r>
+              <a:rPr lang="en-US" sz="1300" b="1" dirty="0">
+                <a:solidFill>
+                  <a:srgbClr val="14213D"/>
+                </a:solidFill>
+                <a:latin typeface="Calibri" pitchFamily="34" charset="0"/>
+                <a:ea typeface="Calibri" pitchFamily="34" charset="-122"/>
+                <a:cs typeface="Calibri" pitchFamily="34" charset="-120"/>
+              </a:rPr>
+              <a:t>New: Scenario tests</a:t>
+            </a:r>
+            <a:endParaRPr lang="en-US" sz="1300" dirty="0"/>
+          </a:p>
+        </p:txBody>
+      </p:sp>
+      <p:sp>
+        <p:nvSpPr>
+          <p:cNvPr id="20" name="Shape 18"/>
+          <p:cNvSpPr/>
+          <p:nvPr/>
+        </p:nvSpPr>
+        <p:spPr>
+          <a:xfrm>
+            <a:off x="3383280" y="3410712"/>
+            <a:ext cx="1508760" cy="502920"/>
+          </a:xfrm>
+          <a:prstGeom prst="roundRect">
+            <a:avLst>
+              <a:gd name="adj" fmla="val 14545"/>
             </a:avLst>
           </a:prstGeom>
           <a:solidFill>
@@ -1300,14 +1773,14 @@
       </p:sp>
       <p:sp>
         <p:nvSpPr>
-          <p:cNvPr id="10" name="Text 8"/>
-          <p:cNvSpPr txBox="1"/>
-          <p:nvPr/>
-        </p:nvSpPr>
-        <p:spPr>
-          <a:xfrm>
-            <a:off x="6931152" y="1261872"/>
-            <a:ext cx="457200" cy="219456"/>
+          <p:cNvPr id="21" name="Text 19"/>
+          <p:cNvSpPr txBox="1"/>
+          <p:nvPr/>
+        </p:nvSpPr>
+        <p:spPr>
+          <a:xfrm>
+            <a:off x="3383280" y="3410712"/>
+            <a:ext cx="1508760" cy="502920"/>
           </a:xfrm>
           <a:prstGeom prst="rect">
             <a:avLst/>
@@ -1319,166 +1792,34 @@
           <a:bodyPr wrap="square" lIns="0" tIns="0" rIns="0" bIns="0" rtlCol="0" anchor="ctr"/>
           <a:lstStyle/>
           <a:p>
-            <a:pPr indent="0" marL="0">
-              <a:buNone/>
-            </a:pPr>
-            <a:r>
-              <a:rPr lang="en-US" sz="1000" dirty="0">
-                <a:solidFill>
-                  <a:srgbClr val="6B7280"/>
-                </a:solidFill>
-                <a:latin typeface="Calibri" pitchFamily="34" charset="0"/>
-                <a:ea typeface="Calibri" pitchFamily="34" charset="-122"/>
-                <a:cs typeface="Calibri" pitchFamily="34" charset="-120"/>
-              </a:rPr>
-              <a:t>New</a:t>
-            </a:r>
-            <a:endParaRPr lang="en-US" sz="1000" dirty="0"/>
-          </a:p>
-        </p:txBody>
-      </p:sp>
-      <p:sp>
-        <p:nvSpPr>
-          <p:cNvPr id="11" name="Shape 9"/>
+            <a:pPr algn="ctr" indent="0" marL="0">
+              <a:buNone/>
+            </a:pPr>
+            <a:r>
+              <a:rPr lang="en-US" sz="1100" b="1" dirty="0">
+                <a:solidFill>
+                  <a:srgbClr val="FFFFFF"/>
+                </a:solidFill>
+                <a:latin typeface="Calibri" pitchFamily="34" charset="0"/>
+                <a:ea typeface="Calibri" pitchFamily="34" charset="-122"/>
+                <a:cs typeface="Calibri" pitchFamily="34" charset="-120"/>
+              </a:rPr>
+              <a:t>Apply real load</a:t>
+            </a:r>
+            <a:endParaRPr lang="en-US" sz="1100" dirty="0"/>
+          </a:p>
+        </p:txBody>
+      </p:sp>
+      <p:sp>
+        <p:nvSpPr>
+          <p:cNvPr id="22" name="Shape 20"/>
           <p:cNvSpPr/>
           <p:nvPr/>
         </p:nvSpPr>
         <p:spPr>
           <a:xfrm>
-            <a:off x="7498080" y="1298448"/>
-            <a:ext cx="164592" cy="146304"/>
-          </a:xfrm>
-          <a:prstGeom prst="roundRect">
-            <a:avLst>
-              <a:gd name="adj" fmla="val 50000"/>
-            </a:avLst>
-          </a:prstGeom>
-          <a:solidFill>
-            <a:srgbClr val="C9D1DB"/>
-          </a:solidFill>
-          <a:ln w="12700">
-            <a:solidFill>
-              <a:srgbClr val="C9D1DB"/>
-            </a:solidFill>
-            <a:prstDash val="solid"/>
-          </a:ln>
-        </p:spPr>
-      </p:sp>
-      <p:sp>
-        <p:nvSpPr>
-          <p:cNvPr id="12" name="Text 10"/>
-          <p:cNvSpPr txBox="1"/>
-          <p:nvPr/>
-        </p:nvSpPr>
-        <p:spPr>
-          <a:xfrm>
-            <a:off x="7708392" y="1261872"/>
-            <a:ext cx="731520" cy="219456"/>
-          </a:xfrm>
-          <a:prstGeom prst="rect">
-            <a:avLst/>
-          </a:prstGeom>
-          <a:noFill/>
-          <a:ln/>
-        </p:spPr>
-        <p:txBody>
-          <a:bodyPr wrap="square" lIns="0" tIns="0" rIns="0" bIns="0" rtlCol="0" anchor="ctr"/>
-          <a:lstStyle/>
-          <a:p>
-            <a:pPr indent="0" marL="0">
-              <a:buNone/>
-            </a:pPr>
-            <a:r>
-              <a:rPr lang="en-US" sz="1000" dirty="0">
-                <a:solidFill>
-                  <a:srgbClr val="6B7280"/>
-                </a:solidFill>
-                <a:latin typeface="Calibri" pitchFamily="34" charset="0"/>
-                <a:ea typeface="Calibri" pitchFamily="34" charset="-122"/>
-                <a:cs typeface="Calibri" pitchFamily="34" charset="-120"/>
-              </a:rPr>
-              <a:t>Existing</a:t>
-            </a:r>
-            <a:endParaRPr lang="en-US" sz="1000" dirty="0"/>
-          </a:p>
-        </p:txBody>
-      </p:sp>
-      <p:sp>
-        <p:nvSpPr>
-          <p:cNvPr id="13" name="Shape 11"/>
-          <p:cNvSpPr/>
-          <p:nvPr/>
-        </p:nvSpPr>
-        <p:spPr>
-          <a:xfrm>
-            <a:off x="4937760" y="1600200"/>
-            <a:ext cx="1828800" cy="347472"/>
-          </a:xfrm>
-          <a:prstGeom prst="roundRect">
-            <a:avLst>
-              <a:gd name="adj" fmla="val 21053"/>
-            </a:avLst>
-          </a:prstGeom>
-          <a:solidFill>
-            <a:srgbClr val="C9D1DB"/>
-          </a:solidFill>
-          <a:ln w="12700">
-            <a:solidFill>
-              <a:srgbClr val="C9D1DB"/>
-            </a:solidFill>
-            <a:prstDash val="solid"/>
-          </a:ln>
-        </p:spPr>
-      </p:sp>
-      <p:sp>
-        <p:nvSpPr>
-          <p:cNvPr id="14" name="Text 12"/>
-          <p:cNvSpPr txBox="1"/>
-          <p:nvPr/>
-        </p:nvSpPr>
-        <p:spPr>
-          <a:xfrm>
-            <a:off x="4937760" y="1600200"/>
-            <a:ext cx="1828800" cy="347472"/>
-          </a:xfrm>
-          <a:prstGeom prst="rect">
-            <a:avLst/>
-          </a:prstGeom>
-          <a:noFill/>
-          <a:ln/>
-        </p:spPr>
-        <p:txBody>
-          <a:bodyPr wrap="square" lIns="0" tIns="0" rIns="0" bIns="0" rtlCol="0" anchor="ctr"/>
-          <a:lstStyle/>
-          <a:p>
-            <a:pPr algn="ctr" indent="0" marL="0">
-              <a:buNone/>
-            </a:pPr>
-            <a:r>
-              <a:rPr lang="en-US" sz="1100" b="1" dirty="0">
-                <a:solidFill>
-                  <a:srgbClr val="1F2937"/>
-                </a:solidFill>
-                <a:latin typeface="Calibri" pitchFamily="34" charset="0"/>
-                <a:ea typeface="Calibri" pitchFamily="34" charset="-122"/>
-                <a:cs typeface="Calibri" pitchFamily="34" charset="-120"/>
-              </a:rPr>
-              <a:t>Kernel test runner</a:t>
-            </a:r>
-            <a:endParaRPr lang="en-US" sz="1100" dirty="0"/>
-          </a:p>
-        </p:txBody>
-      </p:sp>
-      <p:sp>
-        <p:nvSpPr>
-          <p:cNvPr id="15" name="Shape 13"/>
-          <p:cNvSpPr/>
-          <p:nvPr/>
-        </p:nvSpPr>
-        <p:spPr>
-          <a:xfrm>
-            <a:off x="5852160" y="1947672"/>
-            <a:ext cx="-2194560" cy="292608"/>
+            <a:off x="4919472" y="3662172"/>
+            <a:ext cx="265176" cy="0"/>
           </a:xfrm>
           <a:prstGeom prst="line">
             <a:avLst/>
@@ -1495,18 +1836,18 @@
       </p:sp>
       <p:sp>
         <p:nvSpPr>
-          <p:cNvPr id="16" name="Shape 14"/>
+          <p:cNvPr id="23" name="Shape 21"/>
           <p:cNvSpPr/>
           <p:nvPr/>
         </p:nvSpPr>
         <p:spPr>
           <a:xfrm>
-            <a:off x="3017520" y="2240280"/>
-            <a:ext cx="1280160" cy="566928"/>
+            <a:off x="5212080" y="3410712"/>
+            <a:ext cx="1508760" cy="502920"/>
           </a:xfrm>
           <a:prstGeom prst="roundRect">
             <a:avLst>
-              <a:gd name="adj" fmla="val 12903"/>
+              <a:gd name="adj" fmla="val 14545"/>
             </a:avLst>
           </a:prstGeom>
           <a:solidFill>
@@ -1522,14 +1863,14 @@
       </p:sp>
       <p:sp>
         <p:nvSpPr>
-          <p:cNvPr id="17" name="Text 15"/>
-          <p:cNvSpPr txBox="1"/>
-          <p:nvPr/>
-        </p:nvSpPr>
-        <p:spPr>
-          <a:xfrm>
-            <a:off x="3017520" y="2240280"/>
-            <a:ext cx="1280160" cy="566928"/>
+          <p:cNvPr id="24" name="Text 22"/>
+          <p:cNvSpPr txBox="1"/>
+          <p:nvPr/>
+        </p:nvSpPr>
+        <p:spPr>
+          <a:xfrm>
+            <a:off x="5212080" y="3410712"/>
+            <a:ext cx="1508760" cy="502920"/>
           </a:xfrm>
           <a:prstGeom prst="rect">
             <a:avLst/>
@@ -1553,39 +1894,22 @@
                 <a:ea typeface="Calibri" pitchFamily="34" charset="-122"/>
                 <a:cs typeface="Calibri" pitchFamily="34" charset="-120"/>
               </a:rPr>
-              <a:t>Round-robin</a:t>
+              <a:t>Observe behavior</a:t>
             </a:r>
             <a:endParaRPr lang="en-US" sz="1100" dirty="0"/>
           </a:p>
-          <a:p>
-            <a:pPr algn="ctr" indent="0" marL="0">
-              <a:buNone/>
-            </a:pPr>
-            <a:r>
-              <a:rPr lang="en-US" sz="1000" dirty="0">
-                <a:solidFill>
-                  <a:srgbClr val="FFFFFF"/>
-                </a:solidFill>
-                <a:latin typeface="Calibri" pitchFamily="34" charset="0"/>
-                <a:ea typeface="Calibri" pitchFamily="34" charset="-122"/>
-                <a:cs typeface="Calibri" pitchFamily="34" charset="-120"/>
-              </a:rPr>
-              <a:t>2 tests</a:t>
-            </a:r>
-            <a:endParaRPr lang="en-US" sz="1100" dirty="0"/>
-          </a:p>
-        </p:txBody>
-      </p:sp>
-      <p:sp>
-        <p:nvSpPr>
-          <p:cNvPr id="18" name="Shape 16"/>
+        </p:txBody>
+      </p:sp>
+      <p:sp>
+        <p:nvSpPr>
+          <p:cNvPr id="25" name="Shape 23"/>
           <p:cNvSpPr/>
           <p:nvPr/>
         </p:nvSpPr>
         <p:spPr>
           <a:xfrm>
-            <a:off x="5852160" y="1947672"/>
-            <a:ext cx="-731520" cy="292608"/>
+            <a:off x="6748272" y="3662172"/>
+            <a:ext cx="265176" cy="0"/>
           </a:xfrm>
           <a:prstGeom prst="line">
             <a:avLst/>
@@ -1602,26 +1926,26 @@
       </p:sp>
       <p:sp>
         <p:nvSpPr>
-          <p:cNvPr id="19" name="Shape 17"/>
+          <p:cNvPr id="26" name="Shape 24"/>
           <p:cNvSpPr/>
           <p:nvPr/>
         </p:nvSpPr>
         <p:spPr>
           <a:xfrm>
-            <a:off x="4480560" y="2240280"/>
-            <a:ext cx="1280160" cy="566928"/>
+            <a:off x="7040880" y="3410712"/>
+            <a:ext cx="1508760" cy="502920"/>
           </a:xfrm>
           <a:prstGeom prst="roundRect">
             <a:avLst>
-              <a:gd name="adj" fmla="val 12903"/>
+              <a:gd name="adj" fmla="val 14545"/>
             </a:avLst>
           </a:prstGeom>
           <a:solidFill>
-            <a:srgbClr val="0E9F9A"/>
+            <a:srgbClr val="F4A259"/>
           </a:solidFill>
           <a:ln w="12700">
             <a:solidFill>
-              <a:srgbClr val="0E9F9A"/>
+              <a:srgbClr val="F4A259"/>
             </a:solidFill>
             <a:prstDash val="solid"/>
           </a:ln>
@@ -1629,14 +1953,14 @@
       </p:sp>
       <p:sp>
         <p:nvSpPr>
-          <p:cNvPr id="20" name="Text 18"/>
-          <p:cNvSpPr txBox="1"/>
-          <p:nvPr/>
-        </p:nvSpPr>
-        <p:spPr>
-          <a:xfrm>
-            <a:off x="4480560" y="2240280"/>
-            <a:ext cx="1280160" cy="566928"/>
+          <p:cNvPr id="27" name="Text 25"/>
+          <p:cNvSpPr txBox="1"/>
+          <p:nvPr/>
+        </p:nvSpPr>
+        <p:spPr>
+          <a:xfrm>
+            <a:off x="7040880" y="3410712"/>
+            <a:ext cx="1508760" cy="502920"/>
           </a:xfrm>
           <a:prstGeom prst="rect">
             <a:avLst/>
@@ -1654,30 +1978,52 @@
             <a:r>
               <a:rPr lang="en-US" sz="1100" b="1" dirty="0">
                 <a:solidFill>
-                  <a:srgbClr val="FFFFFF"/>
-                </a:solidFill>
-                <a:latin typeface="Calibri" pitchFamily="34" charset="0"/>
-                <a:ea typeface="Calibri" pitchFamily="34" charset="-122"/>
-                <a:cs typeface="Calibri" pitchFamily="34" charset="-120"/>
-              </a:rPr>
-              <a:t>SMP starvation</a:t>
+                  <a:srgbClr val="1F2937"/>
+                </a:solidFill>
+                <a:latin typeface="Calibri" pitchFamily="34" charset="0"/>
+                <a:ea typeface="Calibri" pitchFamily="34" charset="-122"/>
+                <a:cs typeface="Calibri" pitchFamily="34" charset="-120"/>
+              </a:rPr>
+              <a:t>PASS / FAIL</a:t>
             </a:r>
             <a:endParaRPr lang="en-US" sz="1100" dirty="0"/>
           </a:p>
-          <a:p>
-            <a:pPr algn="ctr" indent="0" marL="0">
-              <a:buNone/>
-            </a:pPr>
-            <a:r>
-              <a:rPr lang="en-US" sz="1000" dirty="0">
-                <a:solidFill>
-                  <a:srgbClr val="FFFFFF"/>
-                </a:solidFill>
-                <a:latin typeface="Calibri" pitchFamily="34" charset="0"/>
-                <a:ea typeface="Calibri" pitchFamily="34" charset="-122"/>
-                <a:cs typeface="Calibri" pitchFamily="34" charset="-120"/>
-              </a:rPr>
-              <a:t>1 test</a:t>
+        </p:txBody>
+      </p:sp>
+      <p:sp>
+        <p:nvSpPr>
+          <p:cNvPr id="28" name="Text 26"/>
+          <p:cNvSpPr txBox="1"/>
+          <p:nvPr/>
+        </p:nvSpPr>
+        <p:spPr>
+          <a:xfrm>
+            <a:off x="3383280" y="3977640"/>
+            <a:ext cx="5303520" cy="256032"/>
+          </a:xfrm>
+          <a:prstGeom prst="rect">
+            <a:avLst/>
+          </a:prstGeom>
+          <a:noFill/>
+          <a:ln/>
+        </p:spPr>
+        <p:txBody>
+          <a:bodyPr wrap="square" lIns="0" tIns="0" rIns="0" bIns="0" rtlCol="0" anchor="ctr"/>
+          <a:lstStyle/>
+          <a:p>
+            <a:pPr indent="0" marL="0">
+              <a:buNone/>
+            </a:pPr>
+            <a:r>
+              <a:rPr lang="en-US" sz="1100" i="1" dirty="0">
+                <a:solidFill>
+                  <a:srgbClr val="0E9F9A"/>
+                </a:solidFill>
+                <a:latin typeface="Calibri" pitchFamily="34" charset="0"/>
+                <a:ea typeface="Calibri" pitchFamily="34" charset="-122"/>
+                <a:cs typeface="Calibri" pitchFamily="34" charset="-120"/>
+              </a:rPr>
+              <a:t>Fails when the scheduler misbehaves.</a:t>
             </a:r>
             <a:endParaRPr lang="en-US" sz="1100" dirty="0"/>
           </a:p>
@@ -1685,65 +2031,14 @@
       </p:sp>
       <p:sp>
         <p:nvSpPr>
-          <p:cNvPr id="21" name="Shape 19"/>
-          <p:cNvSpPr/>
-          <p:nvPr/>
-        </p:nvSpPr>
-        <p:spPr>
-          <a:xfrm>
-            <a:off x="5852160" y="1947672"/>
-            <a:ext cx="731520" cy="292608"/>
-          </a:xfrm>
-          <a:prstGeom prst="line">
-            <a:avLst/>
-          </a:prstGeom>
-          <a:noFill/>
-          <a:ln w="19050">
-            <a:solidFill>
-              <a:srgbClr val="6B7280"/>
-            </a:solidFill>
-            <a:prstDash val="solid"/>
-            <a:tailEnd type="triangle"/>
-          </a:ln>
-        </p:spPr>
-      </p:sp>
-      <p:sp>
-        <p:nvSpPr>
-          <p:cNvPr id="22" name="Shape 20"/>
-          <p:cNvSpPr/>
-          <p:nvPr/>
-        </p:nvSpPr>
-        <p:spPr>
-          <a:xfrm>
-            <a:off x="5943600" y="2240280"/>
-            <a:ext cx="1280160" cy="566928"/>
-          </a:xfrm>
-          <a:prstGeom prst="roundRect">
-            <a:avLst>
-              <a:gd name="adj" fmla="val 12903"/>
-            </a:avLst>
-          </a:prstGeom>
-          <a:solidFill>
-            <a:srgbClr val="0E9F9A"/>
-          </a:solidFill>
-          <a:ln w="12700">
-            <a:solidFill>
-              <a:srgbClr val="0E9F9A"/>
-            </a:solidFill>
-            <a:prstDash val="solid"/>
-          </a:ln>
-        </p:spPr>
-      </p:sp>
-      <p:sp>
-        <p:nvSpPr>
-          <p:cNvPr id="23" name="Text 21"/>
-          <p:cNvSpPr txBox="1"/>
-          <p:nvPr/>
-        </p:nvSpPr>
-        <p:spPr>
-          <a:xfrm>
-            <a:off x="5943600" y="2240280"/>
-            <a:ext cx="1280160" cy="566928"/>
+          <p:cNvPr id="29" name="Text 27"/>
+          <p:cNvSpPr txBox="1"/>
+          <p:nvPr/>
+        </p:nvSpPr>
+        <p:spPr>
+          <a:xfrm>
+            <a:off x="3383280" y="4434840"/>
+            <a:ext cx="5303520" cy="274320"/>
           </a:xfrm>
           <a:prstGeom prst="rect">
             <a:avLst/>
@@ -1755,624 +2050,23 @@
           <a:bodyPr wrap="square" lIns="0" tIns="0" rIns="0" bIns="0" rtlCol="0" anchor="ctr"/>
           <a:lstStyle/>
           <a:p>
-            <a:pPr algn="ctr" indent="0" marL="0">
-              <a:buNone/>
-            </a:pPr>
-            <a:r>
-              <a:rPr lang="en-US" sz="1100" b="1" dirty="0">
-                <a:solidFill>
-                  <a:srgbClr val="FFFFFF"/>
-                </a:solidFill>
-                <a:latin typeface="Calibri" pitchFamily="34" charset="0"/>
-                <a:ea typeface="Calibri" pitchFamily="34" charset="-122"/>
-                <a:cs typeface="Calibri" pitchFamily="34" charset="-120"/>
-              </a:rPr>
-              <a:t>Priority</a:t>
-            </a:r>
-            <a:endParaRPr lang="en-US" sz="1100" dirty="0"/>
-          </a:p>
-          <a:p>
-            <a:pPr algn="ctr" indent="0" marL="0">
-              <a:buNone/>
-            </a:pPr>
-            <a:r>
-              <a:rPr lang="en-US" sz="1000" dirty="0">
-                <a:solidFill>
-                  <a:srgbClr val="FFFFFF"/>
-                </a:solidFill>
-                <a:latin typeface="Calibri" pitchFamily="34" charset="0"/>
-                <a:ea typeface="Calibri" pitchFamily="34" charset="-122"/>
-                <a:cs typeface="Calibri" pitchFamily="34" charset="-120"/>
-              </a:rPr>
-              <a:t>4 tests</a:t>
-            </a:r>
-            <a:endParaRPr lang="en-US" sz="1100" dirty="0"/>
-          </a:p>
-        </p:txBody>
-      </p:sp>
-      <p:sp>
-        <p:nvSpPr>
-          <p:cNvPr id="24" name="Shape 22"/>
-          <p:cNvSpPr/>
-          <p:nvPr/>
-        </p:nvSpPr>
-        <p:spPr>
-          <a:xfrm>
-            <a:off x="5852160" y="1947672"/>
-            <a:ext cx="2194560" cy="292608"/>
-          </a:xfrm>
-          <a:prstGeom prst="line">
-            <a:avLst/>
-          </a:prstGeom>
-          <a:noFill/>
-          <a:ln w="19050">
-            <a:solidFill>
-              <a:srgbClr val="6B7280"/>
-            </a:solidFill>
-            <a:prstDash val="solid"/>
-            <a:tailEnd type="triangle"/>
-          </a:ln>
-        </p:spPr>
-      </p:sp>
-      <p:sp>
-        <p:nvSpPr>
-          <p:cNvPr id="25" name="Shape 23"/>
-          <p:cNvSpPr/>
-          <p:nvPr/>
-        </p:nvSpPr>
-        <p:spPr>
-          <a:xfrm>
-            <a:off x="7406640" y="2240280"/>
-            <a:ext cx="1280160" cy="566928"/>
-          </a:xfrm>
-          <a:prstGeom prst="roundRect">
-            <a:avLst>
-              <a:gd name="adj" fmla="val 12903"/>
-            </a:avLst>
-          </a:prstGeom>
-          <a:solidFill>
-            <a:srgbClr val="0E9F9A"/>
-          </a:solidFill>
-          <a:ln w="12700">
-            <a:solidFill>
-              <a:srgbClr val="0E9F9A"/>
-            </a:solidFill>
-            <a:prstDash val="solid"/>
-          </a:ln>
-        </p:spPr>
-      </p:sp>
-      <p:sp>
-        <p:nvSpPr>
-          <p:cNvPr id="26" name="Text 24"/>
-          <p:cNvSpPr txBox="1"/>
-          <p:nvPr/>
-        </p:nvSpPr>
-        <p:spPr>
-          <a:xfrm>
-            <a:off x="7406640" y="2240280"/>
-            <a:ext cx="1280160" cy="566928"/>
-          </a:xfrm>
-          <a:prstGeom prst="rect">
-            <a:avLst/>
-          </a:prstGeom>
-          <a:noFill/>
-          <a:ln/>
-        </p:spPr>
-        <p:txBody>
-          <a:bodyPr wrap="square" lIns="0" tIns="0" rIns="0" bIns="0" rtlCol="0" anchor="ctr"/>
-          <a:lstStyle/>
-          <a:p>
-            <a:pPr algn="ctr" indent="0" marL="0">
-              <a:buNone/>
-            </a:pPr>
-            <a:r>
-              <a:rPr lang="en-US" sz="1100" b="1" dirty="0">
-                <a:solidFill>
-                  <a:srgbClr val="FFFFFF"/>
-                </a:solidFill>
-                <a:latin typeface="Calibri" pitchFamily="34" charset="0"/>
-                <a:ea typeface="Calibri" pitchFamily="34" charset="-122"/>
-                <a:cs typeface="Calibri" pitchFamily="34" charset="-120"/>
-              </a:rPr>
-              <a:t>Affinity</a:t>
-            </a:r>
-            <a:endParaRPr lang="en-US" sz="1100" dirty="0"/>
-          </a:p>
-          <a:p>
-            <a:pPr algn="ctr" indent="0" marL="0">
-              <a:buNone/>
-            </a:pPr>
-            <a:r>
-              <a:rPr lang="en-US" sz="1000" dirty="0">
-                <a:solidFill>
-                  <a:srgbClr val="FFFFFF"/>
-                </a:solidFill>
-                <a:latin typeface="Calibri" pitchFamily="34" charset="0"/>
-                <a:ea typeface="Calibri" pitchFamily="34" charset="-122"/>
-                <a:cs typeface="Calibri" pitchFamily="34" charset="-120"/>
-              </a:rPr>
-              <a:t>5 tests</a:t>
-            </a:r>
-            <a:endParaRPr lang="en-US" sz="1100" dirty="0"/>
-          </a:p>
-        </p:txBody>
-      </p:sp>
-      <p:sp>
-        <p:nvSpPr>
-          <p:cNvPr id="27" name="Shape 25"/>
-          <p:cNvSpPr/>
-          <p:nvPr/>
-        </p:nvSpPr>
-        <p:spPr>
-          <a:xfrm>
-            <a:off x="3017520" y="3108960"/>
-            <a:ext cx="2651760" cy="566928"/>
-          </a:xfrm>
-          <a:prstGeom prst="roundRect">
-            <a:avLst>
-              <a:gd name="adj" fmla="val 12903"/>
-            </a:avLst>
-          </a:prstGeom>
-          <a:solidFill>
-            <a:srgbClr val="14213D"/>
-          </a:solidFill>
-          <a:ln w="12700">
-            <a:solidFill>
-              <a:srgbClr val="14213D"/>
-            </a:solidFill>
-            <a:prstDash val="solid"/>
-          </a:ln>
-        </p:spPr>
-      </p:sp>
-      <p:sp>
-        <p:nvSpPr>
-          <p:cNvPr id="28" name="Text 26"/>
-          <p:cNvSpPr txBox="1"/>
-          <p:nvPr/>
-        </p:nvSpPr>
-        <p:spPr>
-          <a:xfrm>
-            <a:off x="3017520" y="3108960"/>
-            <a:ext cx="2651760" cy="566928"/>
-          </a:xfrm>
-          <a:prstGeom prst="rect">
-            <a:avLst/>
-          </a:prstGeom>
-          <a:noFill/>
-          <a:ln/>
-        </p:spPr>
-        <p:txBody>
-          <a:bodyPr wrap="square" lIns="0" tIns="0" rIns="0" bIns="0" rtlCol="0" anchor="ctr"/>
-          <a:lstStyle/>
-          <a:p>
-            <a:pPr algn="ctr" indent="0" marL="0">
-              <a:buNone/>
-            </a:pPr>
-            <a:r>
-              <a:rPr lang="en-US" sz="1100" b="1" dirty="0">
-                <a:solidFill>
-                  <a:srgbClr val="FFFFFF"/>
-                </a:solidFill>
-                <a:latin typeface="Calibri" pitchFamily="34" charset="0"/>
-                <a:ea typeface="Calibri" pitchFamily="34" charset="-122"/>
-                <a:cs typeface="Calibri" pitchFamily="34" charset="-120"/>
-              </a:rPr>
-              <a:t>Measurement harness</a:t>
-            </a:r>
-            <a:endParaRPr lang="en-US" sz="1100" dirty="0"/>
-          </a:p>
-          <a:p>
-            <a:pPr algn="ctr" indent="0" marL="0">
-              <a:buNone/>
-            </a:pPr>
-            <a:r>
-              <a:rPr lang="en-US" sz="1000" dirty="0">
-                <a:solidFill>
-                  <a:srgbClr val="FFFFFF"/>
-                </a:solidFill>
-                <a:latin typeface="Calibri" pitchFamily="34" charset="0"/>
-                <a:ea typeface="Calibri" pitchFamily="34" charset="-122"/>
-                <a:cs typeface="Calibri" pitchFamily="34" charset="-120"/>
-              </a:rPr>
-              <a:t>Load, measure, verdict</a:t>
-            </a:r>
-            <a:endParaRPr lang="en-US" sz="1100" dirty="0"/>
-          </a:p>
-        </p:txBody>
-      </p:sp>
-      <p:sp>
-        <p:nvSpPr>
-          <p:cNvPr id="29" name="Shape 27"/>
-          <p:cNvSpPr/>
-          <p:nvPr/>
-        </p:nvSpPr>
-        <p:spPr>
-          <a:xfrm>
-            <a:off x="6035040" y="3108960"/>
-            <a:ext cx="2651760" cy="566928"/>
-          </a:xfrm>
-          <a:prstGeom prst="roundRect">
-            <a:avLst>
-              <a:gd name="adj" fmla="val 12903"/>
-            </a:avLst>
-          </a:prstGeom>
-          <a:solidFill>
-            <a:srgbClr val="14213D"/>
-          </a:solidFill>
-          <a:ln w="12700">
-            <a:solidFill>
-              <a:srgbClr val="14213D"/>
-            </a:solidFill>
-            <a:prstDash val="solid"/>
-          </a:ln>
-        </p:spPr>
-      </p:sp>
-      <p:sp>
-        <p:nvSpPr>
-          <p:cNvPr id="30" name="Text 28"/>
-          <p:cNvSpPr txBox="1"/>
-          <p:nvPr/>
-        </p:nvSpPr>
-        <p:spPr>
-          <a:xfrm>
-            <a:off x="6035040" y="3108960"/>
-            <a:ext cx="2651760" cy="566928"/>
-          </a:xfrm>
-          <a:prstGeom prst="rect">
-            <a:avLst/>
-          </a:prstGeom>
-          <a:noFill/>
-          <a:ln/>
-        </p:spPr>
-        <p:txBody>
-          <a:bodyPr wrap="square" lIns="0" tIns="0" rIns="0" bIns="0" rtlCol="0" anchor="ctr"/>
-          <a:lstStyle/>
-          <a:p>
-            <a:pPr algn="ctr" indent="0" marL="0">
-              <a:buNone/>
-            </a:pPr>
-            <a:r>
-              <a:rPr lang="en-US" sz="1100" b="1" dirty="0">
-                <a:solidFill>
-                  <a:srgbClr val="FFFFFF"/>
-                </a:solidFill>
-                <a:latin typeface="Calibri" pitchFamily="34" charset="0"/>
-                <a:ea typeface="Calibri" pitchFamily="34" charset="-122"/>
-                <a:cs typeface="Calibri" pitchFamily="34" charset="-120"/>
-              </a:rPr>
-              <a:t>Starvation monitor</a:t>
-            </a:r>
-            <a:endParaRPr lang="en-US" sz="1100" dirty="0"/>
-          </a:p>
-          <a:p>
-            <a:pPr algn="ctr" indent="0" marL="0">
-              <a:buNone/>
-            </a:pPr>
-            <a:r>
-              <a:rPr lang="en-US" sz="1000" dirty="0">
-                <a:solidFill>
-                  <a:srgbClr val="FFFFFF"/>
-                </a:solidFill>
-                <a:latin typeface="Calibri" pitchFamily="34" charset="0"/>
-                <a:ea typeface="Calibri" pitchFamily="34" charset="-122"/>
-                <a:cs typeface="Calibri" pitchFamily="34" charset="-120"/>
-              </a:rPr>
-              <a:t>Flags stuck tasks</a:t>
-            </a:r>
-            <a:endParaRPr lang="en-US" sz="1100" dirty="0"/>
-          </a:p>
-        </p:txBody>
-      </p:sp>
-      <p:sp>
-        <p:nvSpPr>
-          <p:cNvPr id="31" name="Shape 29"/>
-          <p:cNvSpPr/>
-          <p:nvPr/>
-        </p:nvSpPr>
-        <p:spPr>
-          <a:xfrm>
-            <a:off x="5852160" y="2807208"/>
-            <a:ext cx="-1508760" cy="301752"/>
-          </a:xfrm>
-          <a:prstGeom prst="line">
-            <a:avLst/>
-          </a:prstGeom>
-          <a:noFill/>
-          <a:ln w="19050">
-            <a:solidFill>
-              <a:srgbClr val="6B7280"/>
-            </a:solidFill>
-            <a:prstDash val="solid"/>
-            <a:tailEnd type="triangle"/>
-          </a:ln>
-        </p:spPr>
-      </p:sp>
-      <p:sp>
-        <p:nvSpPr>
-          <p:cNvPr id="32" name="Shape 30"/>
-          <p:cNvSpPr/>
-          <p:nvPr/>
-        </p:nvSpPr>
-        <p:spPr>
-          <a:xfrm>
-            <a:off x="5852160" y="2807208"/>
-            <a:ext cx="1508760" cy="301752"/>
-          </a:xfrm>
-          <a:prstGeom prst="line">
-            <a:avLst/>
-          </a:prstGeom>
-          <a:noFill/>
-          <a:ln w="19050">
-            <a:solidFill>
-              <a:srgbClr val="6B7280"/>
-            </a:solidFill>
-            <a:prstDash val="solid"/>
-            <a:tailEnd type="triangle"/>
-          </a:ln>
-        </p:spPr>
-      </p:sp>
-      <p:sp>
-        <p:nvSpPr>
-          <p:cNvPr id="33" name="Shape 31"/>
-          <p:cNvSpPr/>
-          <p:nvPr/>
-        </p:nvSpPr>
-        <p:spPr>
-          <a:xfrm>
-            <a:off x="3017520" y="3977640"/>
-            <a:ext cx="5669280" cy="731520"/>
-          </a:xfrm>
-          <a:prstGeom prst="roundRect">
-            <a:avLst>
-              <a:gd name="adj" fmla="val 10000"/>
-            </a:avLst>
-          </a:prstGeom>
-          <a:solidFill>
-            <a:srgbClr val="EEF2F6"/>
-          </a:solidFill>
-          <a:ln w="12700">
-            <a:solidFill>
-              <a:srgbClr val="C9D1DB"/>
-            </a:solidFill>
-            <a:prstDash val="solid"/>
-          </a:ln>
-        </p:spPr>
-      </p:sp>
-      <p:sp>
-        <p:nvSpPr>
-          <p:cNvPr id="34" name="Text 32"/>
-          <p:cNvSpPr txBox="1"/>
-          <p:nvPr/>
-        </p:nvSpPr>
-        <p:spPr>
-          <a:xfrm>
-            <a:off x="3200400" y="3977640"/>
-            <a:ext cx="2011680" cy="731520"/>
-          </a:xfrm>
-          <a:prstGeom prst="rect">
-            <a:avLst/>
-          </a:prstGeom>
-          <a:noFill/>
-          <a:ln/>
-        </p:spPr>
-        <p:txBody>
-          <a:bodyPr wrap="square" lIns="0" tIns="0" rIns="0" bIns="0" rtlCol="0" anchor="ctr"/>
-          <a:lstStyle/>
-          <a:p>
             <a:pPr indent="0" marL="0">
               <a:buNone/>
             </a:pPr>
             <a:r>
-              <a:rPr lang="en-US" sz="1100" b="1" dirty="0">
-                <a:solidFill>
-                  <a:srgbClr val="1F2937"/>
-                </a:solidFill>
-                <a:latin typeface="Calibri" pitchFamily="34" charset="0"/>
-                <a:ea typeface="Calibri" pitchFamily="34" charset="-122"/>
-                <a:cs typeface="Calibri" pitchFamily="34" charset="-120"/>
-              </a:rPr>
-              <a:t>TizenRT scheduler</a:t>
-            </a:r>
-            <a:endParaRPr lang="en-US" sz="1100" dirty="0"/>
-          </a:p>
-          <a:p>
-            <a:pPr indent="0" marL="0">
-              <a:buNone/>
-            </a:pPr>
-            <a:r>
-              <a:rPr lang="en-US" sz="1000" dirty="0">
-                <a:solidFill>
-                  <a:srgbClr val="6B7280"/>
-                </a:solidFill>
-                <a:latin typeface="Calibri" pitchFamily="34" charset="0"/>
-                <a:ea typeface="Calibri" pitchFamily="34" charset="-122"/>
-                <a:cs typeface="Calibri" pitchFamily="34" charset="-120"/>
-              </a:rPr>
-              <a:t>Unchanged</a:t>
-            </a:r>
-            <a:endParaRPr lang="en-US" sz="1100" dirty="0"/>
-          </a:p>
-        </p:txBody>
-      </p:sp>
-      <p:sp>
-        <p:nvSpPr>
-          <p:cNvPr id="35" name="Shape 33"/>
-          <p:cNvSpPr/>
-          <p:nvPr/>
-        </p:nvSpPr>
-        <p:spPr>
-          <a:xfrm>
-            <a:off x="5852160" y="4160520"/>
-            <a:ext cx="1143000" cy="365760"/>
-          </a:xfrm>
-          <a:prstGeom prst="roundRect">
-            <a:avLst>
-              <a:gd name="adj" fmla="val 20000"/>
-            </a:avLst>
-          </a:prstGeom>
-          <a:solidFill>
-            <a:srgbClr val="C9D1DB"/>
-          </a:solidFill>
-          <a:ln w="12700">
-            <a:solidFill>
-              <a:srgbClr val="C9D1DB"/>
-            </a:solidFill>
-            <a:prstDash val="solid"/>
-          </a:ln>
-        </p:spPr>
-      </p:sp>
-      <p:sp>
-        <p:nvSpPr>
-          <p:cNvPr id="36" name="Text 34"/>
-          <p:cNvSpPr txBox="1"/>
-          <p:nvPr/>
-        </p:nvSpPr>
-        <p:spPr>
-          <a:xfrm>
-            <a:off x="5852160" y="4160520"/>
-            <a:ext cx="1143000" cy="365760"/>
-          </a:xfrm>
-          <a:prstGeom prst="rect">
-            <a:avLst/>
-          </a:prstGeom>
-          <a:noFill/>
-          <a:ln/>
-        </p:spPr>
-        <p:txBody>
-          <a:bodyPr wrap="square" lIns="0" tIns="0" rIns="0" bIns="0" rtlCol="0" anchor="ctr"/>
-          <a:lstStyle/>
-          <a:p>
-            <a:pPr algn="ctr" indent="0" marL="0">
-              <a:buNone/>
-            </a:pPr>
-            <a:r>
-              <a:rPr lang="en-US" sz="1000" b="1" dirty="0">
-                <a:solidFill>
-                  <a:srgbClr val="1F2937"/>
-                </a:solidFill>
-                <a:latin typeface="Calibri" pitchFamily="34" charset="0"/>
-                <a:ea typeface="Calibri" pitchFamily="34" charset="-122"/>
-                <a:cs typeface="Calibri" pitchFamily="34" charset="-120"/>
-              </a:rPr>
-              <a:t>CPU 0</a:t>
-            </a:r>
-            <a:endParaRPr lang="en-US" sz="1000" dirty="0"/>
-          </a:p>
-        </p:txBody>
-      </p:sp>
-      <p:sp>
-        <p:nvSpPr>
-          <p:cNvPr id="37" name="Shape 35"/>
-          <p:cNvSpPr/>
-          <p:nvPr/>
-        </p:nvSpPr>
-        <p:spPr>
-          <a:xfrm>
-            <a:off x="7223760" y="4160520"/>
-            <a:ext cx="1143000" cy="365760"/>
-          </a:xfrm>
-          <a:prstGeom prst="roundRect">
-            <a:avLst>
-              <a:gd name="adj" fmla="val 20000"/>
-            </a:avLst>
-          </a:prstGeom>
-          <a:solidFill>
-            <a:srgbClr val="C9D1DB"/>
-          </a:solidFill>
-          <a:ln w="12700">
-            <a:solidFill>
-              <a:srgbClr val="C9D1DB"/>
-            </a:solidFill>
-            <a:prstDash val="solid"/>
-          </a:ln>
-        </p:spPr>
-      </p:sp>
-      <p:sp>
-        <p:nvSpPr>
-          <p:cNvPr id="38" name="Text 36"/>
-          <p:cNvSpPr txBox="1"/>
-          <p:nvPr/>
-        </p:nvSpPr>
-        <p:spPr>
-          <a:xfrm>
-            <a:off x="7223760" y="4160520"/>
-            <a:ext cx="1143000" cy="365760"/>
-          </a:xfrm>
-          <a:prstGeom prst="rect">
-            <a:avLst/>
-          </a:prstGeom>
-          <a:noFill/>
-          <a:ln/>
-        </p:spPr>
-        <p:txBody>
-          <a:bodyPr wrap="square" lIns="0" tIns="0" rIns="0" bIns="0" rtlCol="0" anchor="ctr"/>
-          <a:lstStyle/>
-          <a:p>
-            <a:pPr algn="ctr" indent="0" marL="0">
-              <a:buNone/>
-            </a:pPr>
-            <a:r>
-              <a:rPr lang="en-US" sz="1000" b="1" dirty="0">
-                <a:solidFill>
-                  <a:srgbClr val="1F2937"/>
-                </a:solidFill>
-                <a:latin typeface="Calibri" pitchFamily="34" charset="0"/>
-                <a:ea typeface="Calibri" pitchFamily="34" charset="-122"/>
-                <a:cs typeface="Calibri" pitchFamily="34" charset="-120"/>
-              </a:rPr>
-              <a:t>CPU 1</a:t>
-            </a:r>
-            <a:endParaRPr lang="en-US" sz="1000" dirty="0"/>
-          </a:p>
-        </p:txBody>
-      </p:sp>
-      <p:sp>
-        <p:nvSpPr>
-          <p:cNvPr id="39" name="Shape 37"/>
-          <p:cNvSpPr/>
-          <p:nvPr/>
-        </p:nvSpPr>
-        <p:spPr>
-          <a:xfrm>
-            <a:off x="4343400" y="3675888"/>
-            <a:ext cx="0" cy="301752"/>
-          </a:xfrm>
-          <a:prstGeom prst="line">
-            <a:avLst/>
-          </a:prstGeom>
-          <a:noFill/>
-          <a:ln w="19050">
-            <a:solidFill>
-              <a:srgbClr val="6B7280"/>
-            </a:solidFill>
-            <a:prstDash val="solid"/>
-            <a:tailEnd type="triangle"/>
-          </a:ln>
-        </p:spPr>
-      </p:sp>
-      <p:sp>
-        <p:nvSpPr>
-          <p:cNvPr id="40" name="Shape 38"/>
-          <p:cNvSpPr/>
-          <p:nvPr/>
-        </p:nvSpPr>
-        <p:spPr>
-          <a:xfrm>
-            <a:off x="7360920" y="3675888"/>
-            <a:ext cx="0" cy="301752"/>
-          </a:xfrm>
-          <a:prstGeom prst="line">
-            <a:avLst/>
-          </a:prstGeom>
-          <a:noFill/>
-          <a:ln w="19050">
-            <a:solidFill>
-              <a:srgbClr val="6B7280"/>
-            </a:solidFill>
-            <a:prstDash val="solid"/>
-            <a:tailEnd type="triangle"/>
-          </a:ln>
-        </p:spPr>
+              <a:rPr lang="en-US" sz="1200" b="1" dirty="0">
+                <a:solidFill>
+                  <a:srgbClr val="14213D"/>
+                </a:solidFill>
+                <a:latin typeface="Calibri" pitchFamily="34" charset="0"/>
+                <a:ea typeface="Calibri" pitchFamily="34" charset="-122"/>
+                <a:cs typeface="Calibri" pitchFamily="34" charset="-120"/>
+              </a:rPr>
+              <a:t>Goal: prove the scheduler behaves correctly under real load.</a:t>
+            </a:r>
+            <a:endParaRPr lang="en-US" sz="1200" dirty="0"/>
+          </a:p>
+        </p:txBody>
       </p:sp>
     </p:spTree>
   </p:cSld>
@@ -2439,7 +2133,7 @@
                 <a:ea typeface="Cambria" pitchFamily="34" charset="-122"/>
                 <a:cs typeface="Cambria" pitchFamily="34" charset="-120"/>
               </a:rPr>
-              <a:t>How It Works and What It Catches</a:t>
+              <a:t>Solution: What We Added</a:t>
             </a:r>
             <a:endParaRPr lang="en-US" sz="2600" dirty="0"/>
           </a:p>
@@ -2478,7 +2172,7 @@
                 <a:ea typeface="Calibri" pitchFamily="34" charset="-122"/>
                 <a:cs typeface="Calibri" pitchFamily="34" charset="-120"/>
               </a:rPr>
-              <a:t>Real load on real cores. Checks behavior, not return codes.</a:t>
+              <a:t>A new test layer on top of the existing kernel. No kernel code changed.</a:t>
             </a:r>
             <a:endParaRPr lang="en-US" sz="1200" dirty="0"/>
           </a:p>
@@ -2492,12 +2186,638 @@
         </p:nvSpPr>
         <p:spPr>
           <a:xfrm>
-            <a:off x="457200" y="1234440"/>
-            <a:ext cx="1371600" cy="731520"/>
+            <a:off x="457200" y="1298448"/>
+            <a:ext cx="164592" cy="146304"/>
           </a:xfrm>
           <a:prstGeom prst="roundRect">
             <a:avLst>
-              <a:gd name="adj" fmla="val 10000"/>
+              <a:gd name="adj" fmla="val 50000"/>
+            </a:avLst>
+          </a:prstGeom>
+          <a:solidFill>
+            <a:srgbClr val="0E9F9A"/>
+          </a:solidFill>
+          <a:ln w="12700">
+            <a:solidFill>
+              <a:srgbClr val="0E9F9A"/>
+            </a:solidFill>
+            <a:prstDash val="solid"/>
+          </a:ln>
+        </p:spPr>
+      </p:sp>
+      <p:sp>
+        <p:nvSpPr>
+          <p:cNvPr id="5" name="Text 3"/>
+          <p:cNvSpPr txBox="1"/>
+          <p:nvPr/>
+        </p:nvSpPr>
+        <p:spPr>
+          <a:xfrm>
+            <a:off x="667512" y="1261872"/>
+            <a:ext cx="457200" cy="219456"/>
+          </a:xfrm>
+          <a:prstGeom prst="rect">
+            <a:avLst/>
+          </a:prstGeom>
+          <a:noFill/>
+          <a:ln/>
+        </p:spPr>
+        <p:txBody>
+          <a:bodyPr wrap="square" lIns="0" tIns="0" rIns="0" bIns="0" rtlCol="0" anchor="ctr"/>
+          <a:lstStyle/>
+          <a:p>
+            <a:pPr indent="0" marL="0">
+              <a:buNone/>
+            </a:pPr>
+            <a:r>
+              <a:rPr lang="en-US" sz="1000" dirty="0">
+                <a:solidFill>
+                  <a:srgbClr val="6B7280"/>
+                </a:solidFill>
+                <a:latin typeface="Calibri" pitchFamily="34" charset="0"/>
+                <a:ea typeface="Calibri" pitchFamily="34" charset="-122"/>
+                <a:cs typeface="Calibri" pitchFamily="34" charset="-120"/>
+              </a:rPr>
+              <a:t>New</a:t>
+            </a:r>
+            <a:endParaRPr lang="en-US" sz="1000" dirty="0"/>
+          </a:p>
+        </p:txBody>
+      </p:sp>
+      <p:sp>
+        <p:nvSpPr>
+          <p:cNvPr id="6" name="Shape 4"/>
+          <p:cNvSpPr/>
+          <p:nvPr/>
+        </p:nvSpPr>
+        <p:spPr>
+          <a:xfrm>
+            <a:off x="1234440" y="1298448"/>
+            <a:ext cx="164592" cy="146304"/>
+          </a:xfrm>
+          <a:prstGeom prst="roundRect">
+            <a:avLst>
+              <a:gd name="adj" fmla="val 50000"/>
+            </a:avLst>
+          </a:prstGeom>
+          <a:solidFill>
+            <a:srgbClr val="C9D1DB"/>
+          </a:solidFill>
+          <a:ln w="12700">
+            <a:solidFill>
+              <a:srgbClr val="C9D1DB"/>
+            </a:solidFill>
+            <a:prstDash val="solid"/>
+          </a:ln>
+        </p:spPr>
+      </p:sp>
+      <p:sp>
+        <p:nvSpPr>
+          <p:cNvPr id="7" name="Text 5"/>
+          <p:cNvSpPr txBox="1"/>
+          <p:nvPr/>
+        </p:nvSpPr>
+        <p:spPr>
+          <a:xfrm>
+            <a:off x="1444752" y="1261872"/>
+            <a:ext cx="731520" cy="219456"/>
+          </a:xfrm>
+          <a:prstGeom prst="rect">
+            <a:avLst/>
+          </a:prstGeom>
+          <a:noFill/>
+          <a:ln/>
+        </p:spPr>
+        <p:txBody>
+          <a:bodyPr wrap="square" lIns="0" tIns="0" rIns="0" bIns="0" rtlCol="0" anchor="ctr"/>
+          <a:lstStyle/>
+          <a:p>
+            <a:pPr indent="0" marL="0">
+              <a:buNone/>
+            </a:pPr>
+            <a:r>
+              <a:rPr lang="en-US" sz="1000" dirty="0">
+                <a:solidFill>
+                  <a:srgbClr val="6B7280"/>
+                </a:solidFill>
+                <a:latin typeface="Calibri" pitchFamily="34" charset="0"/>
+                <a:ea typeface="Calibri" pitchFamily="34" charset="-122"/>
+                <a:cs typeface="Calibri" pitchFamily="34" charset="-120"/>
+              </a:rPr>
+              <a:t>Existing</a:t>
+            </a:r>
+            <a:endParaRPr lang="en-US" sz="1000" dirty="0"/>
+          </a:p>
+        </p:txBody>
+      </p:sp>
+      <p:sp>
+        <p:nvSpPr>
+          <p:cNvPr id="8" name="Shape 6"/>
+          <p:cNvSpPr/>
+          <p:nvPr/>
+        </p:nvSpPr>
+        <p:spPr>
+          <a:xfrm>
+            <a:off x="2194560" y="1600200"/>
+            <a:ext cx="1828800" cy="347472"/>
+          </a:xfrm>
+          <a:prstGeom prst="roundRect">
+            <a:avLst>
+              <a:gd name="adj" fmla="val 21053"/>
+            </a:avLst>
+          </a:prstGeom>
+          <a:solidFill>
+            <a:srgbClr val="C9D1DB"/>
+          </a:solidFill>
+          <a:ln w="12700">
+            <a:solidFill>
+              <a:srgbClr val="C9D1DB"/>
+            </a:solidFill>
+            <a:prstDash val="solid"/>
+          </a:ln>
+        </p:spPr>
+      </p:sp>
+      <p:sp>
+        <p:nvSpPr>
+          <p:cNvPr id="9" name="Text 7"/>
+          <p:cNvSpPr txBox="1"/>
+          <p:nvPr/>
+        </p:nvSpPr>
+        <p:spPr>
+          <a:xfrm>
+            <a:off x="2194560" y="1600200"/>
+            <a:ext cx="1828800" cy="347472"/>
+          </a:xfrm>
+          <a:prstGeom prst="rect">
+            <a:avLst/>
+          </a:prstGeom>
+          <a:noFill/>
+          <a:ln/>
+        </p:spPr>
+        <p:txBody>
+          <a:bodyPr wrap="square" lIns="0" tIns="0" rIns="0" bIns="0" rtlCol="0" anchor="ctr"/>
+          <a:lstStyle/>
+          <a:p>
+            <a:pPr algn="ctr" indent="0" marL="0">
+              <a:buNone/>
+            </a:pPr>
+            <a:r>
+              <a:rPr lang="en-US" sz="1100" b="1" dirty="0">
+                <a:solidFill>
+                  <a:srgbClr val="1F2937"/>
+                </a:solidFill>
+                <a:latin typeface="Calibri" pitchFamily="34" charset="0"/>
+                <a:ea typeface="Calibri" pitchFamily="34" charset="-122"/>
+                <a:cs typeface="Calibri" pitchFamily="34" charset="-120"/>
+              </a:rPr>
+              <a:t>Kernel test runner</a:t>
+            </a:r>
+            <a:endParaRPr lang="en-US" sz="1100" dirty="0"/>
+          </a:p>
+        </p:txBody>
+      </p:sp>
+      <p:sp>
+        <p:nvSpPr>
+          <p:cNvPr id="10" name="Shape 8"/>
+          <p:cNvSpPr/>
+          <p:nvPr/>
+        </p:nvSpPr>
+        <p:spPr>
+          <a:xfrm>
+            <a:off x="3108960" y="1947672"/>
+            <a:ext cx="-2057400" cy="292608"/>
+          </a:xfrm>
+          <a:prstGeom prst="line">
+            <a:avLst/>
+          </a:prstGeom>
+          <a:noFill/>
+          <a:ln w="19050">
+            <a:solidFill>
+              <a:srgbClr val="6B7280"/>
+            </a:solidFill>
+            <a:prstDash val="solid"/>
+            <a:tailEnd type="triangle"/>
+          </a:ln>
+        </p:spPr>
+      </p:sp>
+      <p:sp>
+        <p:nvSpPr>
+          <p:cNvPr id="11" name="Shape 9"/>
+          <p:cNvSpPr/>
+          <p:nvPr/>
+        </p:nvSpPr>
+        <p:spPr>
+          <a:xfrm>
+            <a:off x="457200" y="2240280"/>
+            <a:ext cx="1188720" cy="566928"/>
+          </a:xfrm>
+          <a:prstGeom prst="roundRect">
+            <a:avLst>
+              <a:gd name="adj" fmla="val 12903"/>
+            </a:avLst>
+          </a:prstGeom>
+          <a:solidFill>
+            <a:srgbClr val="0E9F9A"/>
+          </a:solidFill>
+          <a:ln w="12700">
+            <a:solidFill>
+              <a:srgbClr val="0E9F9A"/>
+            </a:solidFill>
+            <a:prstDash val="solid"/>
+          </a:ln>
+        </p:spPr>
+      </p:sp>
+      <p:sp>
+        <p:nvSpPr>
+          <p:cNvPr id="12" name="Text 10"/>
+          <p:cNvSpPr txBox="1"/>
+          <p:nvPr/>
+        </p:nvSpPr>
+        <p:spPr>
+          <a:xfrm>
+            <a:off x="457200" y="2240280"/>
+            <a:ext cx="1188720" cy="566928"/>
+          </a:xfrm>
+          <a:prstGeom prst="rect">
+            <a:avLst/>
+          </a:prstGeom>
+          <a:noFill/>
+          <a:ln/>
+        </p:spPr>
+        <p:txBody>
+          <a:bodyPr wrap="square" lIns="0" tIns="0" rIns="0" bIns="0" rtlCol="0" anchor="ctr"/>
+          <a:lstStyle/>
+          <a:p>
+            <a:pPr algn="ctr" indent="0" marL="0">
+              <a:buNone/>
+            </a:pPr>
+            <a:r>
+              <a:rPr lang="en-US" sz="1100" b="1" dirty="0">
+                <a:solidFill>
+                  <a:srgbClr val="FFFFFF"/>
+                </a:solidFill>
+                <a:latin typeface="Calibri" pitchFamily="34" charset="0"/>
+                <a:ea typeface="Calibri" pitchFamily="34" charset="-122"/>
+                <a:cs typeface="Calibri" pitchFamily="34" charset="-120"/>
+              </a:rPr>
+              <a:t>Round-robin</a:t>
+            </a:r>
+            <a:endParaRPr lang="en-US" sz="1100" dirty="0"/>
+          </a:p>
+          <a:p>
+            <a:pPr algn="ctr" indent="0" marL="0">
+              <a:buNone/>
+            </a:pPr>
+            <a:r>
+              <a:rPr lang="en-US" sz="1000" dirty="0">
+                <a:solidFill>
+                  <a:srgbClr val="FFFFFF"/>
+                </a:solidFill>
+                <a:latin typeface="Calibri" pitchFamily="34" charset="0"/>
+                <a:ea typeface="Calibri" pitchFamily="34" charset="-122"/>
+                <a:cs typeface="Calibri" pitchFamily="34" charset="-120"/>
+              </a:rPr>
+              <a:t>2 tests</a:t>
+            </a:r>
+            <a:endParaRPr lang="en-US" sz="1100" dirty="0"/>
+          </a:p>
+        </p:txBody>
+      </p:sp>
+      <p:sp>
+        <p:nvSpPr>
+          <p:cNvPr id="13" name="Shape 11"/>
+          <p:cNvSpPr/>
+          <p:nvPr/>
+        </p:nvSpPr>
+        <p:spPr>
+          <a:xfrm>
+            <a:off x="3108960" y="1947672"/>
+            <a:ext cx="-685800" cy="292608"/>
+          </a:xfrm>
+          <a:prstGeom prst="line">
+            <a:avLst/>
+          </a:prstGeom>
+          <a:noFill/>
+          <a:ln w="19050">
+            <a:solidFill>
+              <a:srgbClr val="6B7280"/>
+            </a:solidFill>
+            <a:prstDash val="solid"/>
+            <a:tailEnd type="triangle"/>
+          </a:ln>
+        </p:spPr>
+      </p:sp>
+      <p:sp>
+        <p:nvSpPr>
+          <p:cNvPr id="14" name="Shape 12"/>
+          <p:cNvSpPr/>
+          <p:nvPr/>
+        </p:nvSpPr>
+        <p:spPr>
+          <a:xfrm>
+            <a:off x="1828800" y="2240280"/>
+            <a:ext cx="1188720" cy="566928"/>
+          </a:xfrm>
+          <a:prstGeom prst="roundRect">
+            <a:avLst>
+              <a:gd name="adj" fmla="val 12903"/>
+            </a:avLst>
+          </a:prstGeom>
+          <a:solidFill>
+            <a:srgbClr val="0E9F9A"/>
+          </a:solidFill>
+          <a:ln w="12700">
+            <a:solidFill>
+              <a:srgbClr val="0E9F9A"/>
+            </a:solidFill>
+            <a:prstDash val="solid"/>
+          </a:ln>
+        </p:spPr>
+      </p:sp>
+      <p:sp>
+        <p:nvSpPr>
+          <p:cNvPr id="15" name="Text 13"/>
+          <p:cNvSpPr txBox="1"/>
+          <p:nvPr/>
+        </p:nvSpPr>
+        <p:spPr>
+          <a:xfrm>
+            <a:off x="1828800" y="2240280"/>
+            <a:ext cx="1188720" cy="566928"/>
+          </a:xfrm>
+          <a:prstGeom prst="rect">
+            <a:avLst/>
+          </a:prstGeom>
+          <a:noFill/>
+          <a:ln/>
+        </p:spPr>
+        <p:txBody>
+          <a:bodyPr wrap="square" lIns="0" tIns="0" rIns="0" bIns="0" rtlCol="0" anchor="ctr"/>
+          <a:lstStyle/>
+          <a:p>
+            <a:pPr algn="ctr" indent="0" marL="0">
+              <a:buNone/>
+            </a:pPr>
+            <a:r>
+              <a:rPr lang="en-US" sz="1100" b="1" dirty="0">
+                <a:solidFill>
+                  <a:srgbClr val="FFFFFF"/>
+                </a:solidFill>
+                <a:latin typeface="Calibri" pitchFamily="34" charset="0"/>
+                <a:ea typeface="Calibri" pitchFamily="34" charset="-122"/>
+                <a:cs typeface="Calibri" pitchFamily="34" charset="-120"/>
+              </a:rPr>
+              <a:t>Starvation</a:t>
+            </a:r>
+            <a:endParaRPr lang="en-US" sz="1100" dirty="0"/>
+          </a:p>
+          <a:p>
+            <a:pPr algn="ctr" indent="0" marL="0">
+              <a:buNone/>
+            </a:pPr>
+            <a:r>
+              <a:rPr lang="en-US" sz="1000" dirty="0">
+                <a:solidFill>
+                  <a:srgbClr val="FFFFFF"/>
+                </a:solidFill>
+                <a:latin typeface="Calibri" pitchFamily="34" charset="0"/>
+                <a:ea typeface="Calibri" pitchFamily="34" charset="-122"/>
+                <a:cs typeface="Calibri" pitchFamily="34" charset="-120"/>
+              </a:rPr>
+              <a:t>1 test</a:t>
+            </a:r>
+            <a:endParaRPr lang="en-US" sz="1100" dirty="0"/>
+          </a:p>
+        </p:txBody>
+      </p:sp>
+      <p:sp>
+        <p:nvSpPr>
+          <p:cNvPr id="16" name="Shape 14"/>
+          <p:cNvSpPr/>
+          <p:nvPr/>
+        </p:nvSpPr>
+        <p:spPr>
+          <a:xfrm>
+            <a:off x="3108960" y="1947672"/>
+            <a:ext cx="685800" cy="292608"/>
+          </a:xfrm>
+          <a:prstGeom prst="line">
+            <a:avLst/>
+          </a:prstGeom>
+          <a:noFill/>
+          <a:ln w="19050">
+            <a:solidFill>
+              <a:srgbClr val="6B7280"/>
+            </a:solidFill>
+            <a:prstDash val="solid"/>
+            <a:tailEnd type="triangle"/>
+          </a:ln>
+        </p:spPr>
+      </p:sp>
+      <p:sp>
+        <p:nvSpPr>
+          <p:cNvPr id="17" name="Shape 15"/>
+          <p:cNvSpPr/>
+          <p:nvPr/>
+        </p:nvSpPr>
+        <p:spPr>
+          <a:xfrm>
+            <a:off x="3200400" y="2240280"/>
+            <a:ext cx="1188720" cy="566928"/>
+          </a:xfrm>
+          <a:prstGeom prst="roundRect">
+            <a:avLst>
+              <a:gd name="adj" fmla="val 12903"/>
+            </a:avLst>
+          </a:prstGeom>
+          <a:solidFill>
+            <a:srgbClr val="0E9F9A"/>
+          </a:solidFill>
+          <a:ln w="12700">
+            <a:solidFill>
+              <a:srgbClr val="0E9F9A"/>
+            </a:solidFill>
+            <a:prstDash val="solid"/>
+          </a:ln>
+        </p:spPr>
+      </p:sp>
+      <p:sp>
+        <p:nvSpPr>
+          <p:cNvPr id="18" name="Text 16"/>
+          <p:cNvSpPr txBox="1"/>
+          <p:nvPr/>
+        </p:nvSpPr>
+        <p:spPr>
+          <a:xfrm>
+            <a:off x="3200400" y="2240280"/>
+            <a:ext cx="1188720" cy="566928"/>
+          </a:xfrm>
+          <a:prstGeom prst="rect">
+            <a:avLst/>
+          </a:prstGeom>
+          <a:noFill/>
+          <a:ln/>
+        </p:spPr>
+        <p:txBody>
+          <a:bodyPr wrap="square" lIns="0" tIns="0" rIns="0" bIns="0" rtlCol="0" anchor="ctr"/>
+          <a:lstStyle/>
+          <a:p>
+            <a:pPr algn="ctr" indent="0" marL="0">
+              <a:buNone/>
+            </a:pPr>
+            <a:r>
+              <a:rPr lang="en-US" sz="1100" b="1" dirty="0">
+                <a:solidFill>
+                  <a:srgbClr val="FFFFFF"/>
+                </a:solidFill>
+                <a:latin typeface="Calibri" pitchFamily="34" charset="0"/>
+                <a:ea typeface="Calibri" pitchFamily="34" charset="-122"/>
+                <a:cs typeface="Calibri" pitchFamily="34" charset="-120"/>
+              </a:rPr>
+              <a:t>Priority</a:t>
+            </a:r>
+            <a:endParaRPr lang="en-US" sz="1100" dirty="0"/>
+          </a:p>
+          <a:p>
+            <a:pPr algn="ctr" indent="0" marL="0">
+              <a:buNone/>
+            </a:pPr>
+            <a:r>
+              <a:rPr lang="en-US" sz="1000" dirty="0">
+                <a:solidFill>
+                  <a:srgbClr val="FFFFFF"/>
+                </a:solidFill>
+                <a:latin typeface="Calibri" pitchFamily="34" charset="0"/>
+                <a:ea typeface="Calibri" pitchFamily="34" charset="-122"/>
+                <a:cs typeface="Calibri" pitchFamily="34" charset="-120"/>
+              </a:rPr>
+              <a:t>4 tests</a:t>
+            </a:r>
+            <a:endParaRPr lang="en-US" sz="1100" dirty="0"/>
+          </a:p>
+        </p:txBody>
+      </p:sp>
+      <p:sp>
+        <p:nvSpPr>
+          <p:cNvPr id="19" name="Shape 17"/>
+          <p:cNvSpPr/>
+          <p:nvPr/>
+        </p:nvSpPr>
+        <p:spPr>
+          <a:xfrm>
+            <a:off x="3108960" y="1947672"/>
+            <a:ext cx="2057400" cy="292608"/>
+          </a:xfrm>
+          <a:prstGeom prst="line">
+            <a:avLst/>
+          </a:prstGeom>
+          <a:noFill/>
+          <a:ln w="19050">
+            <a:solidFill>
+              <a:srgbClr val="6B7280"/>
+            </a:solidFill>
+            <a:prstDash val="solid"/>
+            <a:tailEnd type="triangle"/>
+          </a:ln>
+        </p:spPr>
+      </p:sp>
+      <p:sp>
+        <p:nvSpPr>
+          <p:cNvPr id="20" name="Shape 18"/>
+          <p:cNvSpPr/>
+          <p:nvPr/>
+        </p:nvSpPr>
+        <p:spPr>
+          <a:xfrm>
+            <a:off x="4572000" y="2240280"/>
+            <a:ext cx="1188720" cy="566928"/>
+          </a:xfrm>
+          <a:prstGeom prst="roundRect">
+            <a:avLst>
+              <a:gd name="adj" fmla="val 12903"/>
+            </a:avLst>
+          </a:prstGeom>
+          <a:solidFill>
+            <a:srgbClr val="0E9F9A"/>
+          </a:solidFill>
+          <a:ln w="12700">
+            <a:solidFill>
+              <a:srgbClr val="0E9F9A"/>
+            </a:solidFill>
+            <a:prstDash val="solid"/>
+          </a:ln>
+        </p:spPr>
+      </p:sp>
+      <p:sp>
+        <p:nvSpPr>
+          <p:cNvPr id="21" name="Text 19"/>
+          <p:cNvSpPr txBox="1"/>
+          <p:nvPr/>
+        </p:nvSpPr>
+        <p:spPr>
+          <a:xfrm>
+            <a:off x="4572000" y="2240280"/>
+            <a:ext cx="1188720" cy="566928"/>
+          </a:xfrm>
+          <a:prstGeom prst="rect">
+            <a:avLst/>
+          </a:prstGeom>
+          <a:noFill/>
+          <a:ln/>
+        </p:spPr>
+        <p:txBody>
+          <a:bodyPr wrap="square" lIns="0" tIns="0" rIns="0" bIns="0" rtlCol="0" anchor="ctr"/>
+          <a:lstStyle/>
+          <a:p>
+            <a:pPr algn="ctr" indent="0" marL="0">
+              <a:buNone/>
+            </a:pPr>
+            <a:r>
+              <a:rPr lang="en-US" sz="1100" b="1" dirty="0">
+                <a:solidFill>
+                  <a:srgbClr val="FFFFFF"/>
+                </a:solidFill>
+                <a:latin typeface="Calibri" pitchFamily="34" charset="0"/>
+                <a:ea typeface="Calibri" pitchFamily="34" charset="-122"/>
+                <a:cs typeface="Calibri" pitchFamily="34" charset="-120"/>
+              </a:rPr>
+              <a:t>Affinity</a:t>
+            </a:r>
+            <a:endParaRPr lang="en-US" sz="1100" dirty="0"/>
+          </a:p>
+          <a:p>
+            <a:pPr algn="ctr" indent="0" marL="0">
+              <a:buNone/>
+            </a:pPr>
+            <a:r>
+              <a:rPr lang="en-US" sz="1000" dirty="0">
+                <a:solidFill>
+                  <a:srgbClr val="FFFFFF"/>
+                </a:solidFill>
+                <a:latin typeface="Calibri" pitchFamily="34" charset="0"/>
+                <a:ea typeface="Calibri" pitchFamily="34" charset="-122"/>
+                <a:cs typeface="Calibri" pitchFamily="34" charset="-120"/>
+              </a:rPr>
+              <a:t>5 tests</a:t>
+            </a:r>
+            <a:endParaRPr lang="en-US" sz="1100" dirty="0"/>
+          </a:p>
+        </p:txBody>
+      </p:sp>
+      <p:sp>
+        <p:nvSpPr>
+          <p:cNvPr id="22" name="Shape 20"/>
+          <p:cNvSpPr/>
+          <p:nvPr/>
+        </p:nvSpPr>
+        <p:spPr>
+          <a:xfrm>
+            <a:off x="457200" y="3108960"/>
+            <a:ext cx="2468880" cy="566928"/>
+          </a:xfrm>
+          <a:prstGeom prst="roundRect">
+            <a:avLst>
+              <a:gd name="adj" fmla="val 12903"/>
             </a:avLst>
           </a:prstGeom>
           <a:solidFill>
@@ -2513,14 +2833,14 @@
       </p:sp>
       <p:sp>
         <p:nvSpPr>
-          <p:cNvPr id="5" name="Text 3"/>
-          <p:cNvSpPr txBox="1"/>
-          <p:nvPr/>
-        </p:nvSpPr>
-        <p:spPr>
-          <a:xfrm>
-            <a:off x="457200" y="1234440"/>
-            <a:ext cx="1371600" cy="731520"/>
+          <p:cNvPr id="23" name="Text 21"/>
+          <p:cNvSpPr txBox="1"/>
+          <p:nvPr/>
+        </p:nvSpPr>
+        <p:spPr>
+          <a:xfrm>
+            <a:off x="457200" y="3108960"/>
+            <a:ext cx="2468880" cy="566928"/>
           </a:xfrm>
           <a:prstGeom prst="rect">
             <a:avLst/>
@@ -2536,7 +2856,7 @@
               <a:buNone/>
             </a:pPr>
             <a:r>
-              <a:rPr lang="en-US" sz="1200" b="1" dirty="0">
+              <a:rPr lang="en-US" sz="1100" b="1" dirty="0">
                 <a:solidFill>
                   <a:srgbClr val="FFFFFF"/>
                 </a:solidFill>
@@ -2544,9 +2864,9 @@
                 <a:ea typeface="Calibri" pitchFamily="34" charset="-122"/>
                 <a:cs typeface="Calibri" pitchFamily="34" charset="-120"/>
               </a:rPr>
-              <a:t>Create load</a:t>
-            </a:r>
-            <a:endParaRPr lang="en-US" sz="1200" dirty="0"/>
+              <a:t>Measurement harness</a:t>
+            </a:r>
+            <a:endParaRPr lang="en-US" sz="1100" dirty="0"/>
           </a:p>
           <a:p>
             <a:pPr algn="ctr" indent="0" marL="0">
@@ -2561,50 +2881,26 @@
                 <a:ea typeface="Calibri" pitchFamily="34" charset="-122"/>
                 <a:cs typeface="Calibri" pitchFamily="34" charset="-120"/>
               </a:rPr>
-              <a:t>CPU-bound tasks</a:t>
-            </a:r>
-            <a:endParaRPr lang="en-US" sz="1200" dirty="0"/>
-          </a:p>
-        </p:txBody>
-      </p:sp>
-      <p:sp>
-        <p:nvSpPr>
-          <p:cNvPr id="6" name="Shape 4"/>
+              <a:t>Load, measure, verdict</a:t>
+            </a:r>
+            <a:endParaRPr lang="en-US" sz="1100" dirty="0"/>
+          </a:p>
+        </p:txBody>
+      </p:sp>
+      <p:sp>
+        <p:nvSpPr>
+          <p:cNvPr id="24" name="Shape 22"/>
           <p:cNvSpPr/>
           <p:nvPr/>
         </p:nvSpPr>
         <p:spPr>
           <a:xfrm>
-            <a:off x="1856232" y="1600200"/>
-            <a:ext cx="288036" cy="0"/>
-          </a:xfrm>
-          <a:prstGeom prst="line">
-            <a:avLst/>
-          </a:prstGeom>
-          <a:noFill/>
-          <a:ln w="19050">
-            <a:solidFill>
-              <a:srgbClr val="0E9F9A"/>
-            </a:solidFill>
-            <a:prstDash val="solid"/>
-            <a:tailEnd type="triangle"/>
-          </a:ln>
-        </p:spPr>
-      </p:sp>
-      <p:sp>
-        <p:nvSpPr>
-          <p:cNvPr id="7" name="Shape 5"/>
-          <p:cNvSpPr/>
-          <p:nvPr/>
-        </p:nvSpPr>
-        <p:spPr>
-          <a:xfrm>
-            <a:off x="2171700" y="1234440"/>
-            <a:ext cx="1371600" cy="731520"/>
+            <a:off x="3291840" y="3108960"/>
+            <a:ext cx="2468880" cy="566928"/>
           </a:xfrm>
           <a:prstGeom prst="roundRect">
             <a:avLst>
-              <a:gd name="adj" fmla="val 10000"/>
+              <a:gd name="adj" fmla="val 12903"/>
             </a:avLst>
           </a:prstGeom>
           <a:solidFill>
@@ -2620,14 +2916,14 @@
       </p:sp>
       <p:sp>
         <p:nvSpPr>
-          <p:cNvPr id="8" name="Text 6"/>
-          <p:cNvSpPr txBox="1"/>
-          <p:nvPr/>
-        </p:nvSpPr>
-        <p:spPr>
-          <a:xfrm>
-            <a:off x="2171700" y="1234440"/>
-            <a:ext cx="1371600" cy="731520"/>
+          <p:cNvPr id="25" name="Text 23"/>
+          <p:cNvSpPr txBox="1"/>
+          <p:nvPr/>
+        </p:nvSpPr>
+        <p:spPr>
+          <a:xfrm>
+            <a:off x="3291840" y="3108960"/>
+            <a:ext cx="2468880" cy="566928"/>
           </a:xfrm>
           <a:prstGeom prst="rect">
             <a:avLst/>
@@ -2643,7 +2939,7 @@
               <a:buNone/>
             </a:pPr>
             <a:r>
-              <a:rPr lang="en-US" sz="1200" b="1" dirty="0">
+              <a:rPr lang="en-US" sz="1100" b="1" dirty="0">
                 <a:solidFill>
                   <a:srgbClr val="FFFFFF"/>
                 </a:solidFill>
@@ -2651,62 +2947,1005 @@
                 <a:ea typeface="Calibri" pitchFamily="34" charset="-122"/>
                 <a:cs typeface="Calibri" pitchFamily="34" charset="-120"/>
               </a:rPr>
-              <a:t>Warm up</a:t>
+              <a:t>Starvation monitor</a:t>
+            </a:r>
+            <a:endParaRPr lang="en-US" sz="1100" dirty="0"/>
+          </a:p>
+          <a:p>
+            <a:pPr algn="ctr" indent="0" marL="0">
+              <a:buNone/>
+            </a:pPr>
+            <a:r>
+              <a:rPr lang="en-US" sz="1000" dirty="0">
+                <a:solidFill>
+                  <a:srgbClr val="FFFFFF"/>
+                </a:solidFill>
+                <a:latin typeface="Calibri" pitchFamily="34" charset="0"/>
+                <a:ea typeface="Calibri" pitchFamily="34" charset="-122"/>
+                <a:cs typeface="Calibri" pitchFamily="34" charset="-120"/>
+              </a:rPr>
+              <a:t>Flags stuck tasks</a:t>
+            </a:r>
+            <a:endParaRPr lang="en-US" sz="1100" dirty="0"/>
+          </a:p>
+        </p:txBody>
+      </p:sp>
+      <p:sp>
+        <p:nvSpPr>
+          <p:cNvPr id="26" name="Shape 24"/>
+          <p:cNvSpPr/>
+          <p:nvPr/>
+        </p:nvSpPr>
+        <p:spPr>
+          <a:xfrm>
+            <a:off x="3108960" y="2807208"/>
+            <a:ext cx="-1417320" cy="301752"/>
+          </a:xfrm>
+          <a:prstGeom prst="line">
+            <a:avLst/>
+          </a:prstGeom>
+          <a:noFill/>
+          <a:ln w="19050">
+            <a:solidFill>
+              <a:srgbClr val="6B7280"/>
+            </a:solidFill>
+            <a:prstDash val="solid"/>
+            <a:tailEnd type="triangle"/>
+          </a:ln>
+        </p:spPr>
+      </p:sp>
+      <p:sp>
+        <p:nvSpPr>
+          <p:cNvPr id="27" name="Shape 25"/>
+          <p:cNvSpPr/>
+          <p:nvPr/>
+        </p:nvSpPr>
+        <p:spPr>
+          <a:xfrm>
+            <a:off x="3108960" y="2807208"/>
+            <a:ext cx="1417320" cy="301752"/>
+          </a:xfrm>
+          <a:prstGeom prst="line">
+            <a:avLst/>
+          </a:prstGeom>
+          <a:noFill/>
+          <a:ln w="19050">
+            <a:solidFill>
+              <a:srgbClr val="6B7280"/>
+            </a:solidFill>
+            <a:prstDash val="solid"/>
+            <a:tailEnd type="triangle"/>
+          </a:ln>
+        </p:spPr>
+      </p:sp>
+      <p:sp>
+        <p:nvSpPr>
+          <p:cNvPr id="28" name="Shape 26"/>
+          <p:cNvSpPr/>
+          <p:nvPr/>
+        </p:nvSpPr>
+        <p:spPr>
+          <a:xfrm>
+            <a:off x="457200" y="3977640"/>
+            <a:ext cx="5303520" cy="731520"/>
+          </a:xfrm>
+          <a:prstGeom prst="roundRect">
+            <a:avLst>
+              <a:gd name="adj" fmla="val 10000"/>
+            </a:avLst>
+          </a:prstGeom>
+          <a:solidFill>
+            <a:srgbClr val="EEF2F6"/>
+          </a:solidFill>
+          <a:ln w="12700">
+            <a:solidFill>
+              <a:srgbClr val="C9D1DB"/>
+            </a:solidFill>
+            <a:prstDash val="solid"/>
+          </a:ln>
+        </p:spPr>
+      </p:sp>
+      <p:sp>
+        <p:nvSpPr>
+          <p:cNvPr id="29" name="Text 27"/>
+          <p:cNvSpPr txBox="1"/>
+          <p:nvPr/>
+        </p:nvSpPr>
+        <p:spPr>
+          <a:xfrm>
+            <a:off x="640080" y="3977640"/>
+            <a:ext cx="1828800" cy="731520"/>
+          </a:xfrm>
+          <a:prstGeom prst="rect">
+            <a:avLst/>
+          </a:prstGeom>
+          <a:noFill/>
+          <a:ln/>
+        </p:spPr>
+        <p:txBody>
+          <a:bodyPr wrap="square" lIns="0" tIns="0" rIns="0" bIns="0" rtlCol="0" anchor="ctr"/>
+          <a:lstStyle/>
+          <a:p>
+            <a:pPr indent="0" marL="0">
+              <a:buNone/>
+            </a:pPr>
+            <a:r>
+              <a:rPr lang="en-US" sz="1100" b="1" dirty="0">
+                <a:solidFill>
+                  <a:srgbClr val="1F2937"/>
+                </a:solidFill>
+                <a:latin typeface="Calibri" pitchFamily="34" charset="0"/>
+                <a:ea typeface="Calibri" pitchFamily="34" charset="-122"/>
+                <a:cs typeface="Calibri" pitchFamily="34" charset="-120"/>
+              </a:rPr>
+              <a:t>TizenRT scheduler</a:t>
+            </a:r>
+            <a:endParaRPr lang="en-US" sz="1100" dirty="0"/>
+          </a:p>
+          <a:p>
+            <a:pPr indent="0" marL="0">
+              <a:buNone/>
+            </a:pPr>
+            <a:r>
+              <a:rPr lang="en-US" sz="1000" dirty="0">
+                <a:solidFill>
+                  <a:srgbClr val="6B7280"/>
+                </a:solidFill>
+                <a:latin typeface="Calibri" pitchFamily="34" charset="0"/>
+                <a:ea typeface="Calibri" pitchFamily="34" charset="-122"/>
+                <a:cs typeface="Calibri" pitchFamily="34" charset="-120"/>
+              </a:rPr>
+              <a:t>Unchanged</a:t>
+            </a:r>
+            <a:endParaRPr lang="en-US" sz="1100" dirty="0"/>
+          </a:p>
+        </p:txBody>
+      </p:sp>
+      <p:sp>
+        <p:nvSpPr>
+          <p:cNvPr id="30" name="Shape 28"/>
+          <p:cNvSpPr/>
+          <p:nvPr/>
+        </p:nvSpPr>
+        <p:spPr>
+          <a:xfrm>
+            <a:off x="2971800" y="4160520"/>
+            <a:ext cx="1143000" cy="365760"/>
+          </a:xfrm>
+          <a:prstGeom prst="roundRect">
+            <a:avLst>
+              <a:gd name="adj" fmla="val 20000"/>
+            </a:avLst>
+          </a:prstGeom>
+          <a:solidFill>
+            <a:srgbClr val="C9D1DB"/>
+          </a:solidFill>
+          <a:ln w="12700">
+            <a:solidFill>
+              <a:srgbClr val="C9D1DB"/>
+            </a:solidFill>
+            <a:prstDash val="solid"/>
+          </a:ln>
+        </p:spPr>
+      </p:sp>
+      <p:sp>
+        <p:nvSpPr>
+          <p:cNvPr id="31" name="Text 29"/>
+          <p:cNvSpPr txBox="1"/>
+          <p:nvPr/>
+        </p:nvSpPr>
+        <p:spPr>
+          <a:xfrm>
+            <a:off x="2971800" y="4160520"/>
+            <a:ext cx="1143000" cy="365760"/>
+          </a:xfrm>
+          <a:prstGeom prst="rect">
+            <a:avLst/>
+          </a:prstGeom>
+          <a:noFill/>
+          <a:ln/>
+        </p:spPr>
+        <p:txBody>
+          <a:bodyPr wrap="square" lIns="0" tIns="0" rIns="0" bIns="0" rtlCol="0" anchor="ctr"/>
+          <a:lstStyle/>
+          <a:p>
+            <a:pPr algn="ctr" indent="0" marL="0">
+              <a:buNone/>
+            </a:pPr>
+            <a:r>
+              <a:rPr lang="en-US" sz="1000" b="1" dirty="0">
+                <a:solidFill>
+                  <a:srgbClr val="1F2937"/>
+                </a:solidFill>
+                <a:latin typeface="Calibri" pitchFamily="34" charset="0"/>
+                <a:ea typeface="Calibri" pitchFamily="34" charset="-122"/>
+                <a:cs typeface="Calibri" pitchFamily="34" charset="-120"/>
+              </a:rPr>
+              <a:t>CPU 0</a:t>
+            </a:r>
+            <a:endParaRPr lang="en-US" sz="1000" dirty="0"/>
+          </a:p>
+        </p:txBody>
+      </p:sp>
+      <p:sp>
+        <p:nvSpPr>
+          <p:cNvPr id="32" name="Shape 30"/>
+          <p:cNvSpPr/>
+          <p:nvPr/>
+        </p:nvSpPr>
+        <p:spPr>
+          <a:xfrm>
+            <a:off x="4343400" y="4160520"/>
+            <a:ext cx="1143000" cy="365760"/>
+          </a:xfrm>
+          <a:prstGeom prst="roundRect">
+            <a:avLst>
+              <a:gd name="adj" fmla="val 20000"/>
+            </a:avLst>
+          </a:prstGeom>
+          <a:solidFill>
+            <a:srgbClr val="C9D1DB"/>
+          </a:solidFill>
+          <a:ln w="12700">
+            <a:solidFill>
+              <a:srgbClr val="C9D1DB"/>
+            </a:solidFill>
+            <a:prstDash val="solid"/>
+          </a:ln>
+        </p:spPr>
+      </p:sp>
+      <p:sp>
+        <p:nvSpPr>
+          <p:cNvPr id="33" name="Text 31"/>
+          <p:cNvSpPr txBox="1"/>
+          <p:nvPr/>
+        </p:nvSpPr>
+        <p:spPr>
+          <a:xfrm>
+            <a:off x="4343400" y="4160520"/>
+            <a:ext cx="1143000" cy="365760"/>
+          </a:xfrm>
+          <a:prstGeom prst="rect">
+            <a:avLst/>
+          </a:prstGeom>
+          <a:noFill/>
+          <a:ln/>
+        </p:spPr>
+        <p:txBody>
+          <a:bodyPr wrap="square" lIns="0" tIns="0" rIns="0" bIns="0" rtlCol="0" anchor="ctr"/>
+          <a:lstStyle/>
+          <a:p>
+            <a:pPr algn="ctr" indent="0" marL="0">
+              <a:buNone/>
+            </a:pPr>
+            <a:r>
+              <a:rPr lang="en-US" sz="1000" b="1" dirty="0">
+                <a:solidFill>
+                  <a:srgbClr val="1F2937"/>
+                </a:solidFill>
+                <a:latin typeface="Calibri" pitchFamily="34" charset="0"/>
+                <a:ea typeface="Calibri" pitchFamily="34" charset="-122"/>
+                <a:cs typeface="Calibri" pitchFamily="34" charset="-120"/>
+              </a:rPr>
+              <a:t>CPU 1</a:t>
+            </a:r>
+            <a:endParaRPr lang="en-US" sz="1000" dirty="0"/>
+          </a:p>
+        </p:txBody>
+      </p:sp>
+      <p:sp>
+        <p:nvSpPr>
+          <p:cNvPr id="34" name="Shape 32"/>
+          <p:cNvSpPr/>
+          <p:nvPr/>
+        </p:nvSpPr>
+        <p:spPr>
+          <a:xfrm>
+            <a:off x="1691640" y="3675888"/>
+            <a:ext cx="0" cy="301752"/>
+          </a:xfrm>
+          <a:prstGeom prst="line">
+            <a:avLst/>
+          </a:prstGeom>
+          <a:noFill/>
+          <a:ln w="19050">
+            <a:solidFill>
+              <a:srgbClr val="6B7280"/>
+            </a:solidFill>
+            <a:prstDash val="solid"/>
+            <a:tailEnd type="triangle"/>
+          </a:ln>
+        </p:spPr>
+      </p:sp>
+      <p:sp>
+        <p:nvSpPr>
+          <p:cNvPr id="35" name="Shape 33"/>
+          <p:cNvSpPr/>
+          <p:nvPr/>
+        </p:nvSpPr>
+        <p:spPr>
+          <a:xfrm>
+            <a:off x="4526280" y="3675888"/>
+            <a:ext cx="0" cy="301752"/>
+          </a:xfrm>
+          <a:prstGeom prst="line">
+            <a:avLst/>
+          </a:prstGeom>
+          <a:noFill/>
+          <a:ln w="19050">
+            <a:solidFill>
+              <a:srgbClr val="6B7280"/>
+            </a:solidFill>
+            <a:prstDash val="solid"/>
+            <a:tailEnd type="triangle"/>
+          </a:ln>
+        </p:spPr>
+      </p:sp>
+      <p:sp>
+        <p:nvSpPr>
+          <p:cNvPr id="36" name="Shape 34"/>
+          <p:cNvSpPr/>
+          <p:nvPr/>
+        </p:nvSpPr>
+        <p:spPr>
+          <a:xfrm>
+            <a:off x="6126480" y="1234440"/>
+            <a:ext cx="2560320" cy="3474720"/>
+          </a:xfrm>
+          <a:prstGeom prst="roundRect">
+            <a:avLst>
+              <a:gd name="adj" fmla="val 2857"/>
+            </a:avLst>
+          </a:prstGeom>
+          <a:solidFill>
+            <a:srgbClr val="EEF2F6"/>
+          </a:solidFill>
+          <a:ln w="12700">
+            <a:solidFill>
+              <a:srgbClr val="EEF2F6"/>
+            </a:solidFill>
+            <a:prstDash val="solid"/>
+          </a:ln>
+        </p:spPr>
+      </p:sp>
+      <p:sp>
+        <p:nvSpPr>
+          <p:cNvPr id="37" name="Text 35"/>
+          <p:cNvSpPr txBox="1"/>
+          <p:nvPr/>
+        </p:nvSpPr>
+        <p:spPr>
+          <a:xfrm>
+            <a:off x="6309360" y="1371600"/>
+            <a:ext cx="4114800" cy="274320"/>
+          </a:xfrm>
+          <a:prstGeom prst="rect">
+            <a:avLst/>
+          </a:prstGeom>
+          <a:noFill/>
+          <a:ln/>
+        </p:spPr>
+        <p:txBody>
+          <a:bodyPr wrap="square" lIns="0" tIns="0" rIns="0" bIns="0" rtlCol="0" anchor="ctr"/>
+          <a:lstStyle/>
+          <a:p>
+            <a:pPr indent="0" marL="0">
+              <a:buNone/>
+            </a:pPr>
+            <a:r>
+              <a:rPr lang="en-US" sz="1200" b="1" spc="200" kern="0" dirty="0">
+                <a:solidFill>
+                  <a:srgbClr val="0E9F9A"/>
+                </a:solidFill>
+                <a:latin typeface="Calibri" pitchFamily="34" charset="0"/>
+                <a:ea typeface="Calibri" pitchFamily="34" charset="-122"/>
+                <a:cs typeface="Calibri" pitchFamily="34" charset="-120"/>
+              </a:rPr>
+              <a:t>DESIGN POINTS</a:t>
             </a:r>
             <a:endParaRPr lang="en-US" sz="1200" dirty="0"/>
           </a:p>
-          <a:p>
-            <a:pPr algn="ctr" indent="0" marL="0">
-              <a:buNone/>
-            </a:pPr>
-            <a:r>
-              <a:rPr lang="en-US" sz="1000" dirty="0">
-                <a:solidFill>
-                  <a:srgbClr val="FFFFFF"/>
-                </a:solidFill>
-                <a:latin typeface="Calibri" pitchFamily="34" charset="0"/>
-                <a:ea typeface="Calibri" pitchFamily="34" charset="-122"/>
-                <a:cs typeface="Calibri" pitchFamily="34" charset="-120"/>
-              </a:rPr>
-              <a:t>200 ms, discarded</a:t>
-            </a:r>
-            <a:endParaRPr lang="en-US" sz="1200" dirty="0"/>
-          </a:p>
-        </p:txBody>
-      </p:sp>
-      <p:sp>
-        <p:nvSpPr>
-          <p:cNvPr id="9" name="Shape 7"/>
+        </p:txBody>
+      </p:sp>
+      <p:sp>
+        <p:nvSpPr>
+          <p:cNvPr id="38" name="Shape 36"/>
           <p:cNvSpPr/>
           <p:nvPr/>
         </p:nvSpPr>
         <p:spPr>
           <a:xfrm>
-            <a:off x="3570732" y="1600200"/>
-            <a:ext cx="288036" cy="0"/>
-          </a:xfrm>
-          <a:prstGeom prst="line">
-            <a:avLst/>
-          </a:prstGeom>
-          <a:noFill/>
-          <a:ln w="19050">
+            <a:off x="6309360" y="1783080"/>
+            <a:ext cx="310896" cy="310896"/>
+          </a:xfrm>
+          <a:prstGeom prst="ellipse">
+            <a:avLst/>
+          </a:prstGeom>
+          <a:solidFill>
+            <a:srgbClr val="0E9F9A"/>
+          </a:solidFill>
+          <a:ln w="12700">
             <a:solidFill>
               <a:srgbClr val="0E9F9A"/>
             </a:solidFill>
             <a:prstDash val="solid"/>
-            <a:tailEnd type="triangle"/>
           </a:ln>
         </p:spPr>
       </p:sp>
       <p:sp>
         <p:nvSpPr>
-          <p:cNvPr id="10" name="Shape 8"/>
+          <p:cNvPr id="39" name="Text 37"/>
+          <p:cNvSpPr txBox="1"/>
+          <p:nvPr/>
+        </p:nvSpPr>
+        <p:spPr>
+          <a:xfrm>
+            <a:off x="6309360" y="1783080"/>
+            <a:ext cx="310896" cy="310896"/>
+          </a:xfrm>
+          <a:prstGeom prst="rect">
+            <a:avLst/>
+          </a:prstGeom>
+          <a:noFill/>
+          <a:ln/>
+        </p:spPr>
+        <p:txBody>
+          <a:bodyPr wrap="square" lIns="0" tIns="0" rIns="0" bIns="0" rtlCol="0" anchor="ctr"/>
+          <a:lstStyle/>
+          <a:p>
+            <a:pPr algn="ctr" indent="0" marL="0">
+              <a:buNone/>
+            </a:pPr>
+            <a:r>
+              <a:rPr lang="en-US" sz="1100" b="1" dirty="0">
+                <a:solidFill>
+                  <a:srgbClr val="FFFFFF"/>
+                </a:solidFill>
+                <a:latin typeface="Calibri" pitchFamily="34" charset="0"/>
+                <a:ea typeface="Calibri" pitchFamily="34" charset="-122"/>
+                <a:cs typeface="Calibri" pitchFamily="34" charset="-120"/>
+              </a:rPr>
+              <a:t>1</a:t>
+            </a:r>
+            <a:endParaRPr lang="en-US" sz="1100" dirty="0"/>
+          </a:p>
+        </p:txBody>
+      </p:sp>
+      <p:sp>
+        <p:nvSpPr>
+          <p:cNvPr id="40" name="Text 38"/>
+          <p:cNvSpPr txBox="1"/>
+          <p:nvPr/>
+        </p:nvSpPr>
+        <p:spPr>
+          <a:xfrm>
+            <a:off x="6720840" y="1746504"/>
+            <a:ext cx="1874520" cy="566928"/>
+          </a:xfrm>
+          <a:prstGeom prst="rect">
+            <a:avLst/>
+          </a:prstGeom>
+          <a:noFill/>
+          <a:ln/>
+        </p:spPr>
+        <p:txBody>
+          <a:bodyPr wrap="square" lIns="0" tIns="0" rIns="0" bIns="0" rtlCol="0" anchor="t"/>
+          <a:lstStyle/>
+          <a:p>
+            <a:pPr indent="0" marL="0">
+              <a:buNone/>
+            </a:pPr>
+            <a:r>
+              <a:rPr lang="en-US" sz="1200" b="1" dirty="0">
+                <a:solidFill>
+                  <a:srgbClr val="14213D"/>
+                </a:solidFill>
+                <a:latin typeface="Calibri" pitchFamily="34" charset="0"/>
+                <a:ea typeface="Calibri" pitchFamily="34" charset="-122"/>
+                <a:cs typeface="Calibri" pitchFamily="34" charset="-120"/>
+              </a:rPr>
+              <a:t>Work, not time</a:t>
+            </a:r>
+            <a:endParaRPr lang="en-US" sz="1200" dirty="0"/>
+          </a:p>
+          <a:p>
+            <a:pPr indent="0" marL="0">
+              <a:buNone/>
+            </a:pPr>
+            <a:r>
+              <a:rPr lang="en-US" sz="1100" dirty="0">
+                <a:solidFill>
+                  <a:srgbClr val="1F2937"/>
+                </a:solidFill>
+                <a:latin typeface="Calibri" pitchFamily="34" charset="0"/>
+                <a:ea typeface="Calibri" pitchFamily="34" charset="-122"/>
+                <a:cs typeface="Calibri" pitchFamily="34" charset="-120"/>
+              </a:rPr>
+              <a:t>Counts work done per task.</a:t>
+            </a:r>
+            <a:endParaRPr lang="en-US" sz="1200" dirty="0"/>
+          </a:p>
+        </p:txBody>
+      </p:sp>
+      <p:sp>
+        <p:nvSpPr>
+          <p:cNvPr id="41" name="Shape 39"/>
           <p:cNvSpPr/>
           <p:nvPr/>
         </p:nvSpPr>
         <p:spPr>
           <a:xfrm>
-            <a:off x="3886200" y="1234440"/>
+            <a:off x="6309360" y="2496312"/>
+            <a:ext cx="310896" cy="310896"/>
+          </a:xfrm>
+          <a:prstGeom prst="ellipse">
+            <a:avLst/>
+          </a:prstGeom>
+          <a:solidFill>
+            <a:srgbClr val="0E9F9A"/>
+          </a:solidFill>
+          <a:ln w="12700">
+            <a:solidFill>
+              <a:srgbClr val="0E9F9A"/>
+            </a:solidFill>
+            <a:prstDash val="solid"/>
+          </a:ln>
+        </p:spPr>
+      </p:sp>
+      <p:sp>
+        <p:nvSpPr>
+          <p:cNvPr id="42" name="Text 40"/>
+          <p:cNvSpPr txBox="1"/>
+          <p:nvPr/>
+        </p:nvSpPr>
+        <p:spPr>
+          <a:xfrm>
+            <a:off x="6309360" y="2496312"/>
+            <a:ext cx="310896" cy="310896"/>
+          </a:xfrm>
+          <a:prstGeom prst="rect">
+            <a:avLst/>
+          </a:prstGeom>
+          <a:noFill/>
+          <a:ln/>
+        </p:spPr>
+        <p:txBody>
+          <a:bodyPr wrap="square" lIns="0" tIns="0" rIns="0" bIns="0" rtlCol="0" anchor="ctr"/>
+          <a:lstStyle/>
+          <a:p>
+            <a:pPr algn="ctr" indent="0" marL="0">
+              <a:buNone/>
+            </a:pPr>
+            <a:r>
+              <a:rPr lang="en-US" sz="1100" b="1" dirty="0">
+                <a:solidFill>
+                  <a:srgbClr val="FFFFFF"/>
+                </a:solidFill>
+                <a:latin typeface="Calibri" pitchFamily="34" charset="0"/>
+                <a:ea typeface="Calibri" pitchFamily="34" charset="-122"/>
+                <a:cs typeface="Calibri" pitchFamily="34" charset="-120"/>
+              </a:rPr>
+              <a:t>2</a:t>
+            </a:r>
+            <a:endParaRPr lang="en-US" sz="1100" dirty="0"/>
+          </a:p>
+        </p:txBody>
+      </p:sp>
+      <p:sp>
+        <p:nvSpPr>
+          <p:cNvPr id="43" name="Text 41"/>
+          <p:cNvSpPr txBox="1"/>
+          <p:nvPr/>
+        </p:nvSpPr>
+        <p:spPr>
+          <a:xfrm>
+            <a:off x="6720840" y="2459736"/>
+            <a:ext cx="1874520" cy="566928"/>
+          </a:xfrm>
+          <a:prstGeom prst="rect">
+            <a:avLst/>
+          </a:prstGeom>
+          <a:noFill/>
+          <a:ln/>
+        </p:spPr>
+        <p:txBody>
+          <a:bodyPr wrap="square" lIns="0" tIns="0" rIns="0" bIns="0" rtlCol="0" anchor="t"/>
+          <a:lstStyle/>
+          <a:p>
+            <a:pPr indent="0" marL="0">
+              <a:buNone/>
+            </a:pPr>
+            <a:r>
+              <a:rPr lang="en-US" sz="1200" b="1" dirty="0">
+                <a:solidFill>
+                  <a:srgbClr val="14213D"/>
+                </a:solidFill>
+                <a:latin typeface="Calibri" pitchFamily="34" charset="0"/>
+                <a:ea typeface="Calibri" pitchFamily="34" charset="-122"/>
+                <a:cs typeface="Calibri" pitchFamily="34" charset="-120"/>
+              </a:rPr>
+              <a:t>Per-core counters</a:t>
+            </a:r>
+            <a:endParaRPr lang="en-US" sz="1200" dirty="0"/>
+          </a:p>
+          <a:p>
+            <a:pPr indent="0" marL="0">
+              <a:buNone/>
+            </a:pPr>
+            <a:r>
+              <a:rPr lang="en-US" sz="1100" dirty="0">
+                <a:solidFill>
+                  <a:srgbClr val="1F2937"/>
+                </a:solidFill>
+                <a:latin typeface="Calibri" pitchFamily="34" charset="0"/>
+                <a:ea typeface="Calibri" pitchFamily="34" charset="-122"/>
+                <a:cs typeface="Calibri" pitchFamily="34" charset="-120"/>
+              </a:rPr>
+              <a:t>No cross-core distortion.</a:t>
+            </a:r>
+            <a:endParaRPr lang="en-US" sz="1200" dirty="0"/>
+          </a:p>
+        </p:txBody>
+      </p:sp>
+      <p:sp>
+        <p:nvSpPr>
+          <p:cNvPr id="44" name="Shape 42"/>
+          <p:cNvSpPr/>
+          <p:nvPr/>
+        </p:nvSpPr>
+        <p:spPr>
+          <a:xfrm>
+            <a:off x="6309360" y="3209544"/>
+            <a:ext cx="310896" cy="310896"/>
+          </a:xfrm>
+          <a:prstGeom prst="ellipse">
+            <a:avLst/>
+          </a:prstGeom>
+          <a:solidFill>
+            <a:srgbClr val="0E9F9A"/>
+          </a:solidFill>
+          <a:ln w="12700">
+            <a:solidFill>
+              <a:srgbClr val="0E9F9A"/>
+            </a:solidFill>
+            <a:prstDash val="solid"/>
+          </a:ln>
+        </p:spPr>
+      </p:sp>
+      <p:sp>
+        <p:nvSpPr>
+          <p:cNvPr id="45" name="Text 43"/>
+          <p:cNvSpPr txBox="1"/>
+          <p:nvPr/>
+        </p:nvSpPr>
+        <p:spPr>
+          <a:xfrm>
+            <a:off x="6309360" y="3209544"/>
+            <a:ext cx="310896" cy="310896"/>
+          </a:xfrm>
+          <a:prstGeom prst="rect">
+            <a:avLst/>
+          </a:prstGeom>
+          <a:noFill/>
+          <a:ln/>
+        </p:spPr>
+        <p:txBody>
+          <a:bodyPr wrap="square" lIns="0" tIns="0" rIns="0" bIns="0" rtlCol="0" anchor="ctr"/>
+          <a:lstStyle/>
+          <a:p>
+            <a:pPr algn="ctr" indent="0" marL="0">
+              <a:buNone/>
+            </a:pPr>
+            <a:r>
+              <a:rPr lang="en-US" sz="1100" b="1" dirty="0">
+                <a:solidFill>
+                  <a:srgbClr val="FFFFFF"/>
+                </a:solidFill>
+                <a:latin typeface="Calibri" pitchFamily="34" charset="0"/>
+                <a:ea typeface="Calibri" pitchFamily="34" charset="-122"/>
+                <a:cs typeface="Calibri" pitchFamily="34" charset="-120"/>
+              </a:rPr>
+              <a:t>3</a:t>
+            </a:r>
+            <a:endParaRPr lang="en-US" sz="1100" dirty="0"/>
+          </a:p>
+        </p:txBody>
+      </p:sp>
+      <p:sp>
+        <p:nvSpPr>
+          <p:cNvPr id="46" name="Text 44"/>
+          <p:cNvSpPr txBox="1"/>
+          <p:nvPr/>
+        </p:nvSpPr>
+        <p:spPr>
+          <a:xfrm>
+            <a:off x="6720840" y="3172968"/>
+            <a:ext cx="1874520" cy="566928"/>
+          </a:xfrm>
+          <a:prstGeom prst="rect">
+            <a:avLst/>
+          </a:prstGeom>
+          <a:noFill/>
+          <a:ln/>
+        </p:spPr>
+        <p:txBody>
+          <a:bodyPr wrap="square" lIns="0" tIns="0" rIns="0" bIns="0" rtlCol="0" anchor="t"/>
+          <a:lstStyle/>
+          <a:p>
+            <a:pPr indent="0" marL="0">
+              <a:buNone/>
+            </a:pPr>
+            <a:r>
+              <a:rPr lang="en-US" sz="1200" b="1" dirty="0">
+                <a:solidFill>
+                  <a:srgbClr val="14213D"/>
+                </a:solidFill>
+                <a:latin typeface="Calibri" pitchFamily="34" charset="0"/>
+                <a:ea typeface="Calibri" pitchFamily="34" charset="-122"/>
+                <a:cs typeface="Calibri" pitchFamily="34" charset="-120"/>
+              </a:rPr>
+              <a:t>Safe cleanup</a:t>
+            </a:r>
+            <a:endParaRPr lang="en-US" sz="1200" dirty="0"/>
+          </a:p>
+          <a:p>
+            <a:pPr indent="0" marL="0">
+              <a:buNone/>
+            </a:pPr>
+            <a:r>
+              <a:rPr lang="en-US" sz="1100" dirty="0">
+                <a:solidFill>
+                  <a:srgbClr val="1F2937"/>
+                </a:solidFill>
+                <a:latin typeface="Calibri" pitchFamily="34" charset="0"/>
+                <a:ea typeface="Calibri" pitchFamily="34" charset="-122"/>
+                <a:cs typeface="Calibri" pitchFamily="34" charset="-120"/>
+              </a:rPr>
+              <a:t>Tasks stop before any verdict.</a:t>
+            </a:r>
+            <a:endParaRPr lang="en-US" sz="1200" dirty="0"/>
+          </a:p>
+        </p:txBody>
+      </p:sp>
+      <p:sp>
+        <p:nvSpPr>
+          <p:cNvPr id="47" name="Shape 45"/>
+          <p:cNvSpPr/>
+          <p:nvPr/>
+        </p:nvSpPr>
+        <p:spPr>
+          <a:xfrm>
+            <a:off x="6309360" y="3922776"/>
+            <a:ext cx="310896" cy="310896"/>
+          </a:xfrm>
+          <a:prstGeom prst="ellipse">
+            <a:avLst/>
+          </a:prstGeom>
+          <a:solidFill>
+            <a:srgbClr val="0E9F9A"/>
+          </a:solidFill>
+          <a:ln w="12700">
+            <a:solidFill>
+              <a:srgbClr val="0E9F9A"/>
+            </a:solidFill>
+            <a:prstDash val="solid"/>
+          </a:ln>
+        </p:spPr>
+      </p:sp>
+      <p:sp>
+        <p:nvSpPr>
+          <p:cNvPr id="48" name="Text 46"/>
+          <p:cNvSpPr txBox="1"/>
+          <p:nvPr/>
+        </p:nvSpPr>
+        <p:spPr>
+          <a:xfrm>
+            <a:off x="6309360" y="3922776"/>
+            <a:ext cx="310896" cy="310896"/>
+          </a:xfrm>
+          <a:prstGeom prst="rect">
+            <a:avLst/>
+          </a:prstGeom>
+          <a:noFill/>
+          <a:ln/>
+        </p:spPr>
+        <p:txBody>
+          <a:bodyPr wrap="square" lIns="0" tIns="0" rIns="0" bIns="0" rtlCol="0" anchor="ctr"/>
+          <a:lstStyle/>
+          <a:p>
+            <a:pPr algn="ctr" indent="0" marL="0">
+              <a:buNone/>
+            </a:pPr>
+            <a:r>
+              <a:rPr lang="en-US" sz="1100" b="1" dirty="0">
+                <a:solidFill>
+                  <a:srgbClr val="FFFFFF"/>
+                </a:solidFill>
+                <a:latin typeface="Calibri" pitchFamily="34" charset="0"/>
+                <a:ea typeface="Calibri" pitchFamily="34" charset="-122"/>
+                <a:cs typeface="Calibri" pitchFamily="34" charset="-120"/>
+              </a:rPr>
+              <a:t>4</a:t>
+            </a:r>
+            <a:endParaRPr lang="en-US" sz="1100" dirty="0"/>
+          </a:p>
+        </p:txBody>
+      </p:sp>
+      <p:sp>
+        <p:nvSpPr>
+          <p:cNvPr id="49" name="Text 47"/>
+          <p:cNvSpPr txBox="1"/>
+          <p:nvPr/>
+        </p:nvSpPr>
+        <p:spPr>
+          <a:xfrm>
+            <a:off x="6720840" y="3886200"/>
+            <a:ext cx="1874520" cy="566928"/>
+          </a:xfrm>
+          <a:prstGeom prst="rect">
+            <a:avLst/>
+          </a:prstGeom>
+          <a:noFill/>
+          <a:ln/>
+        </p:spPr>
+        <p:txBody>
+          <a:bodyPr wrap="square" lIns="0" tIns="0" rIns="0" bIns="0" rtlCol="0" anchor="t"/>
+          <a:lstStyle/>
+          <a:p>
+            <a:pPr indent="0" marL="0">
+              <a:buNone/>
+            </a:pPr>
+            <a:r>
+              <a:rPr lang="en-US" sz="1200" b="1" dirty="0">
+                <a:solidFill>
+                  <a:srgbClr val="14213D"/>
+                </a:solidFill>
+                <a:latin typeface="Calibri" pitchFamily="34" charset="0"/>
+                <a:ea typeface="Calibri" pitchFamily="34" charset="-122"/>
+                <a:cs typeface="Calibri" pitchFamily="34" charset="-120"/>
+              </a:rPr>
+              <a:t>Opt-in</a:t>
+            </a:r>
+            <a:endParaRPr lang="en-US" sz="1200" dirty="0"/>
+          </a:p>
+          <a:p>
+            <a:pPr indent="0" marL="0">
+              <a:buNone/>
+            </a:pPr>
+            <a:r>
+              <a:rPr lang="en-US" sz="1100" dirty="0">
+                <a:solidFill>
+                  <a:srgbClr val="1F2937"/>
+                </a:solidFill>
+                <a:latin typeface="Calibri" pitchFamily="34" charset="0"/>
+                <a:ea typeface="Calibri" pitchFamily="34" charset="-122"/>
+                <a:cs typeface="Calibri" pitchFamily="34" charset="-120"/>
+              </a:rPr>
+              <a:t>Off by default. Zero risk.</a:t>
+            </a:r>
+            <a:endParaRPr lang="en-US" sz="1200" dirty="0"/>
+          </a:p>
+        </p:txBody>
+      </p:sp>
+    </p:spTree>
+  </p:cSld>
+  <p:clrMapOvr>
+    <a:masterClrMapping/>
+  </p:clrMapOvr>
+</p:sld>
+</file>
+
+<file path=ppt/slides/slide3.xml><?xml version="1.0" encoding="utf-8"?>
+<p:sld xmlns:a="http://schemas.openxmlformats.org/drawingml/2006/main" xmlns:r="http://schemas.openxmlformats.org/officeDocument/2006/relationships" xmlns:p="http://schemas.openxmlformats.org/presentationml/2006/main">
+  <p:cSld name="Slide 3">
+    <p:bg>
+      <p:bgPr>
+        <a:solidFill>
+          <a:srgbClr val="FFFFFF"/>
+        </a:solidFill>
+      </p:bgPr>
+    </p:bg>
+    <p:spTree>
+      <p:nvGrpSpPr>
+        <p:cNvPr id="1" name=""/>
+        <p:cNvGrpSpPr/>
+        <p:nvPr/>
+      </p:nvGrpSpPr>
+      <p:grpSpPr>
+        <a:xfrm>
+          <a:off x="0" y="0"/>
+          <a:ext cx="0" cy="0"/>
+          <a:chOff x="0" y="0"/>
+          <a:chExt cx="0" cy="0"/>
+        </a:xfrm>
+      </p:grpSpPr>
+      <p:sp>
+        <p:nvSpPr>
+          <p:cNvPr id="2" name="Text 0"/>
+          <p:cNvSpPr txBox="1"/>
+          <p:nvPr/>
+        </p:nvSpPr>
+        <p:spPr>
+          <a:xfrm>
+            <a:off x="457200" y="274320"/>
+            <a:ext cx="8229600" cy="457200"/>
+          </a:xfrm>
+          <a:prstGeom prst="rect">
+            <a:avLst/>
+          </a:prstGeom>
+          <a:noFill/>
+          <a:ln/>
+        </p:spPr>
+        <p:txBody>
+          <a:bodyPr wrap="square" lIns="0" tIns="0" rIns="0" bIns="0" rtlCol="0" anchor="ctr"/>
+          <a:lstStyle/>
+          <a:p>
+            <a:pPr indent="0" marL="0">
+              <a:buNone/>
+            </a:pPr>
+            <a:r>
+              <a:rPr lang="en-US" sz="2600" b="1" dirty="0">
+                <a:solidFill>
+                  <a:srgbClr val="14213D"/>
+                </a:solidFill>
+                <a:latin typeface="Cambria" pitchFamily="34" charset="0"/>
+                <a:ea typeface="Cambria" pitchFamily="34" charset="-122"/>
+                <a:cs typeface="Cambria" pitchFamily="34" charset="-120"/>
+              </a:rPr>
+              <a:t>How It Works and What It Catches</a:t>
+            </a:r>
+            <a:endParaRPr lang="en-US" sz="2600" dirty="0"/>
+          </a:p>
+        </p:txBody>
+      </p:sp>
+      <p:sp>
+        <p:nvSpPr>
+          <p:cNvPr id="3" name="Text 1"/>
+          <p:cNvSpPr txBox="1"/>
+          <p:nvPr/>
+        </p:nvSpPr>
+        <p:spPr>
+          <a:xfrm>
+            <a:off x="457200" y="731520"/>
+            <a:ext cx="8229600" cy="274320"/>
+          </a:xfrm>
+          <a:prstGeom prst="rect">
+            <a:avLst/>
+          </a:prstGeom>
+          <a:noFill/>
+          <a:ln/>
+        </p:spPr>
+        <p:txBody>
+          <a:bodyPr wrap="square" lIns="0" tIns="0" rIns="0" bIns="0" rtlCol="0" anchor="ctr"/>
+          <a:lstStyle/>
+          <a:p>
+            <a:pPr indent="0" marL="0">
+              <a:buNone/>
+            </a:pPr>
+            <a:r>
+              <a:rPr lang="en-US" sz="1200" dirty="0">
+                <a:solidFill>
+                  <a:srgbClr val="6B7280"/>
+                </a:solidFill>
+                <a:latin typeface="Calibri" pitchFamily="34" charset="0"/>
+                <a:ea typeface="Calibri" pitchFamily="34" charset="-122"/>
+                <a:cs typeface="Calibri" pitchFamily="34" charset="-120"/>
+              </a:rPr>
+              <a:t>Real load on real cores. Checks behavior, not return codes.</a:t>
+            </a:r>
+            <a:endParaRPr lang="en-US" sz="1200" dirty="0"/>
+          </a:p>
+        </p:txBody>
+      </p:sp>
+      <p:sp>
+        <p:nvSpPr>
+          <p:cNvPr id="4" name="Shape 2"/>
+          <p:cNvSpPr/>
+          <p:nvPr/>
+        </p:nvSpPr>
+        <p:spPr>
+          <a:xfrm>
+            <a:off x="457200" y="1234440"/>
             <a:ext cx="1371600" cy="731520"/>
           </a:xfrm>
           <a:prstGeom prst="roundRect">
@@ -2727,13 +3966,13 @@
       </p:sp>
       <p:sp>
         <p:nvSpPr>
-          <p:cNvPr id="11" name="Text 9"/>
-          <p:cNvSpPr txBox="1"/>
-          <p:nvPr/>
-        </p:nvSpPr>
-        <p:spPr>
-          <a:xfrm>
-            <a:off x="3886200" y="1234440"/>
+          <p:cNvPr id="5" name="Text 3"/>
+          <p:cNvSpPr txBox="1"/>
+          <p:nvPr/>
+        </p:nvSpPr>
+        <p:spPr>
+          <a:xfrm>
+            <a:off x="457200" y="1234440"/>
             <a:ext cx="1371600" cy="731520"/>
           </a:xfrm>
           <a:prstGeom prst="rect">
@@ -2758,7 +3997,7 @@
                 <a:ea typeface="Calibri" pitchFamily="34" charset="-122"/>
                 <a:cs typeface="Calibri" pitchFamily="34" charset="-120"/>
               </a:rPr>
-              <a:t>Measure</a:t>
+              <a:t>Create load</a:t>
             </a:r>
             <a:endParaRPr lang="en-US" sz="1200" dirty="0"/>
           </a:p>
@@ -2775,7 +4014,7 @@
                 <a:ea typeface="Calibri" pitchFamily="34" charset="-122"/>
                 <a:cs typeface="Calibri" pitchFamily="34" charset="-120"/>
               </a:rPr>
-              <a:t>1 to 3 s window</a:t>
+              <a:t>CPU-bound tasks</a:t>
             </a:r>
             <a:endParaRPr lang="en-US" sz="1200" dirty="0"/>
           </a:p>
@@ -2783,13 +4022,13 @@
       </p:sp>
       <p:sp>
         <p:nvSpPr>
-          <p:cNvPr id="12" name="Shape 10"/>
+          <p:cNvPr id="6" name="Shape 4"/>
           <p:cNvSpPr/>
           <p:nvPr/>
         </p:nvSpPr>
         <p:spPr>
           <a:xfrm>
-            <a:off x="5285232" y="1600200"/>
+            <a:off x="1856232" y="1600200"/>
             <a:ext cx="288036" cy="0"/>
           </a:xfrm>
           <a:prstGeom prst="line">
@@ -2807,13 +4046,13 @@
       </p:sp>
       <p:sp>
         <p:nvSpPr>
-          <p:cNvPr id="13" name="Shape 11"/>
+          <p:cNvPr id="7" name="Shape 5"/>
           <p:cNvSpPr/>
           <p:nvPr/>
         </p:nvSpPr>
         <p:spPr>
           <a:xfrm>
-            <a:off x="5600700" y="1234440"/>
+            <a:off x="2171700" y="1234440"/>
             <a:ext cx="1371600" cy="731520"/>
           </a:xfrm>
           <a:prstGeom prst="roundRect">
@@ -2834,6 +4073,220 @@
       </p:sp>
       <p:sp>
         <p:nvSpPr>
+          <p:cNvPr id="8" name="Text 6"/>
+          <p:cNvSpPr txBox="1"/>
+          <p:nvPr/>
+        </p:nvSpPr>
+        <p:spPr>
+          <a:xfrm>
+            <a:off x="2171700" y="1234440"/>
+            <a:ext cx="1371600" cy="731520"/>
+          </a:xfrm>
+          <a:prstGeom prst="rect">
+            <a:avLst/>
+          </a:prstGeom>
+          <a:noFill/>
+          <a:ln/>
+        </p:spPr>
+        <p:txBody>
+          <a:bodyPr wrap="square" lIns="0" tIns="0" rIns="0" bIns="0" rtlCol="0" anchor="ctr"/>
+          <a:lstStyle/>
+          <a:p>
+            <a:pPr algn="ctr" indent="0" marL="0">
+              <a:buNone/>
+            </a:pPr>
+            <a:r>
+              <a:rPr lang="en-US" sz="1200" b="1" dirty="0">
+                <a:solidFill>
+                  <a:srgbClr val="FFFFFF"/>
+                </a:solidFill>
+                <a:latin typeface="Calibri" pitchFamily="34" charset="0"/>
+                <a:ea typeface="Calibri" pitchFamily="34" charset="-122"/>
+                <a:cs typeface="Calibri" pitchFamily="34" charset="-120"/>
+              </a:rPr>
+              <a:t>Warm up</a:t>
+            </a:r>
+            <a:endParaRPr lang="en-US" sz="1200" dirty="0"/>
+          </a:p>
+          <a:p>
+            <a:pPr algn="ctr" indent="0" marL="0">
+              <a:buNone/>
+            </a:pPr>
+            <a:r>
+              <a:rPr lang="en-US" sz="1000" dirty="0">
+                <a:solidFill>
+                  <a:srgbClr val="FFFFFF"/>
+                </a:solidFill>
+                <a:latin typeface="Calibri" pitchFamily="34" charset="0"/>
+                <a:ea typeface="Calibri" pitchFamily="34" charset="-122"/>
+                <a:cs typeface="Calibri" pitchFamily="34" charset="-120"/>
+              </a:rPr>
+              <a:t>200 ms, discarded</a:t>
+            </a:r>
+            <a:endParaRPr lang="en-US" sz="1200" dirty="0"/>
+          </a:p>
+        </p:txBody>
+      </p:sp>
+      <p:sp>
+        <p:nvSpPr>
+          <p:cNvPr id="9" name="Shape 7"/>
+          <p:cNvSpPr/>
+          <p:nvPr/>
+        </p:nvSpPr>
+        <p:spPr>
+          <a:xfrm>
+            <a:off x="3570732" y="1600200"/>
+            <a:ext cx="288036" cy="0"/>
+          </a:xfrm>
+          <a:prstGeom prst="line">
+            <a:avLst/>
+          </a:prstGeom>
+          <a:noFill/>
+          <a:ln w="19050">
+            <a:solidFill>
+              <a:srgbClr val="0E9F9A"/>
+            </a:solidFill>
+            <a:prstDash val="solid"/>
+            <a:tailEnd type="triangle"/>
+          </a:ln>
+        </p:spPr>
+      </p:sp>
+      <p:sp>
+        <p:nvSpPr>
+          <p:cNvPr id="10" name="Shape 8"/>
+          <p:cNvSpPr/>
+          <p:nvPr/>
+        </p:nvSpPr>
+        <p:spPr>
+          <a:xfrm>
+            <a:off x="3886200" y="1234440"/>
+            <a:ext cx="1371600" cy="731520"/>
+          </a:xfrm>
+          <a:prstGeom prst="roundRect">
+            <a:avLst>
+              <a:gd name="adj" fmla="val 10000"/>
+            </a:avLst>
+          </a:prstGeom>
+          <a:solidFill>
+            <a:srgbClr val="14213D"/>
+          </a:solidFill>
+          <a:ln w="12700">
+            <a:solidFill>
+              <a:srgbClr val="14213D"/>
+            </a:solidFill>
+            <a:prstDash val="solid"/>
+          </a:ln>
+        </p:spPr>
+      </p:sp>
+      <p:sp>
+        <p:nvSpPr>
+          <p:cNvPr id="11" name="Text 9"/>
+          <p:cNvSpPr txBox="1"/>
+          <p:nvPr/>
+        </p:nvSpPr>
+        <p:spPr>
+          <a:xfrm>
+            <a:off x="3886200" y="1234440"/>
+            <a:ext cx="1371600" cy="731520"/>
+          </a:xfrm>
+          <a:prstGeom prst="rect">
+            <a:avLst/>
+          </a:prstGeom>
+          <a:noFill/>
+          <a:ln/>
+        </p:spPr>
+        <p:txBody>
+          <a:bodyPr wrap="square" lIns="0" tIns="0" rIns="0" bIns="0" rtlCol="0" anchor="ctr"/>
+          <a:lstStyle/>
+          <a:p>
+            <a:pPr algn="ctr" indent="0" marL="0">
+              <a:buNone/>
+            </a:pPr>
+            <a:r>
+              <a:rPr lang="en-US" sz="1200" b="1" dirty="0">
+                <a:solidFill>
+                  <a:srgbClr val="FFFFFF"/>
+                </a:solidFill>
+                <a:latin typeface="Calibri" pitchFamily="34" charset="0"/>
+                <a:ea typeface="Calibri" pitchFamily="34" charset="-122"/>
+                <a:cs typeface="Calibri" pitchFamily="34" charset="-120"/>
+              </a:rPr>
+              <a:t>Measure</a:t>
+            </a:r>
+            <a:endParaRPr lang="en-US" sz="1200" dirty="0"/>
+          </a:p>
+          <a:p>
+            <a:pPr algn="ctr" indent="0" marL="0">
+              <a:buNone/>
+            </a:pPr>
+            <a:r>
+              <a:rPr lang="en-US" sz="1000" dirty="0">
+                <a:solidFill>
+                  <a:srgbClr val="FFFFFF"/>
+                </a:solidFill>
+                <a:latin typeface="Calibri" pitchFamily="34" charset="0"/>
+                <a:ea typeface="Calibri" pitchFamily="34" charset="-122"/>
+                <a:cs typeface="Calibri" pitchFamily="34" charset="-120"/>
+              </a:rPr>
+              <a:t>1 to 3 s window</a:t>
+            </a:r>
+            <a:endParaRPr lang="en-US" sz="1200" dirty="0"/>
+          </a:p>
+        </p:txBody>
+      </p:sp>
+      <p:sp>
+        <p:nvSpPr>
+          <p:cNvPr id="12" name="Shape 10"/>
+          <p:cNvSpPr/>
+          <p:nvPr/>
+        </p:nvSpPr>
+        <p:spPr>
+          <a:xfrm>
+            <a:off x="5285232" y="1600200"/>
+            <a:ext cx="288036" cy="0"/>
+          </a:xfrm>
+          <a:prstGeom prst="line">
+            <a:avLst/>
+          </a:prstGeom>
+          <a:noFill/>
+          <a:ln w="19050">
+            <a:solidFill>
+              <a:srgbClr val="0E9F9A"/>
+            </a:solidFill>
+            <a:prstDash val="solid"/>
+            <a:tailEnd type="triangle"/>
+          </a:ln>
+        </p:spPr>
+      </p:sp>
+      <p:sp>
+        <p:nvSpPr>
+          <p:cNvPr id="13" name="Shape 11"/>
+          <p:cNvSpPr/>
+          <p:nvPr/>
+        </p:nvSpPr>
+        <p:spPr>
+          <a:xfrm>
+            <a:off x="5600700" y="1234440"/>
+            <a:ext cx="1371600" cy="731520"/>
+          </a:xfrm>
+          <a:prstGeom prst="roundRect">
+            <a:avLst>
+              <a:gd name="adj" fmla="val 10000"/>
+            </a:avLst>
+          </a:prstGeom>
+          <a:solidFill>
+            <a:srgbClr val="14213D"/>
+          </a:solidFill>
+          <a:ln w="12700">
+            <a:solidFill>
+              <a:srgbClr val="14213D"/>
+            </a:solidFill>
+            <a:prstDash val="solid"/>
+          </a:ln>
+        </p:spPr>
+      </p:sp>
+      <p:sp>
+        <p:nvSpPr>
           <p:cNvPr id="14" name="Text 12"/>
           <p:cNvSpPr txBox="1"/>
           <p:nvPr/>
@@ -3004,7 +4457,7 @@
         <p:spPr>
           <a:xfrm>
             <a:off x="457200" y="2194560"/>
-            <a:ext cx="3657600" cy="274320"/>
+            <a:ext cx="4114800" cy="274320"/>
           </a:xfrm>
           <a:prstGeom prst="rect">
             <a:avLst/>
@@ -3719,7 +5172,7 @@
         <p:spPr>
           <a:xfrm>
             <a:off x="457200" y="3639312"/>
-            <a:ext cx="3657600" cy="274320"/>
+            <a:ext cx="4114800" cy="274320"/>
           </a:xfrm>
           <a:prstGeom prst="rect">
             <a:avLst/>

</xml_diff>